<commit_message>
feat(docs): recreate tech pitch deck with emerald green theme, remove all blue/black
- Fresh 17-slide tech pitch covering full SAGE capabilities (136 endpoints,
  30 pages, 840+ tests, 20 agent roles, 14 domains, framework comparison)
- Replace all blue (#0078D4) and black (#0D1B2A) colors with emerald green
  (#10B981) and charcoal gray (#1F2A37) across all PPT generators
- Fix remaining Apache 2.0 badge references → MIT in comparison docs
- Regenerate all 3 PPTX files with consistent white+emerald theme

Co-Authored-By: Claude Opus 4.6 <noreply@anthropic.com>
</commit_message>
<xml_diff>
--- a/docs/SageAI_Investor_Pitch.pptx
+++ b/docs/SageAI_Investor_Pitch.pptx
@@ -18,7 +18,6 @@
     <p:sldId id="266" r:id="rId17"/>
     <p:sldId id="267" r:id="rId18"/>
     <p:sldId id="268" r:id="rId19"/>
-    <p:sldId id="270" r:id="rId21"/>
     <p:sldId id="269" r:id="rId20"/>
   </p:sldIdLst>
   <p:sldSz cx="12188952" cy="6858000" type="screen4x3"/>
@@ -3117,7 +3116,7 @@
             <a:avLst/>
           </a:prstGeom>
           <a:solidFill>
-            <a:srgbClr val="0D1B2A"/>
+            <a:srgbClr val="1F2A37"/>
           </a:solidFill>
           <a:ln>
             <a:noFill/>
@@ -3160,7 +3159,7 @@
             <a:avLst/>
           </a:prstGeom>
           <a:solidFill>
-            <a:srgbClr val="00B4D8"/>
+            <a:srgbClr val="047857"/>
           </a:solidFill>
           <a:ln>
             <a:noFill/>
@@ -3203,7 +3202,7 @@
             <a:avLst/>
           </a:prstGeom>
           <a:solidFill>
-            <a:srgbClr val="0078D4"/>
+            <a:srgbClr val="10B981"/>
           </a:solidFill>
           <a:ln>
             <a:noFill/>
@@ -3291,7 +3290,7 @@
             <a:r>
               <a:rPr sz="2400" b="0" i="0">
                 <a:solidFill>
-                  <a:srgbClr val="00B4D8"/>
+                  <a:srgbClr val="047857"/>
                 </a:solidFill>
               </a:rPr>
               <a:t>Smart Agentic-Guided Empowerment</a:t>
@@ -3325,7 +3324,7 @@
             <a:r>
               <a:rPr sz="1800" b="0" i="1">
                 <a:solidFill>
-                  <a:srgbClr val="647487"/>
+                  <a:srgbClr val="4B5563"/>
                 </a:solidFill>
               </a:rPr>
               <a:t>Autonomous AI Agent Infrastructure for Regulated Industries</a:t>
@@ -3359,10 +3358,10 @@
             <a:r>
               <a:rPr sz="1300" b="0" i="0">
                 <a:solidFill>
-                  <a:srgbClr val="647487"/>
-                </a:solidFill>
-              </a:rPr>
-              <a:t>Investor Presentation — March 2026 — Open Source (Apache 2.0)</a:t>
+                  <a:srgbClr val="4B5563"/>
+                </a:solidFill>
+              </a:rPr>
+              <a:t>Investor Presentation — March 2026 — Open Source (MIT)</a:t>
             </a:r>
           </a:p>
         </p:txBody>
@@ -3381,7 +3380,7 @@
     <p:bg>
       <p:bgPr>
         <a:solidFill>
-          <a:srgbClr val="F0F4F8"/>
+          <a:srgbClr val="FAFAFA"/>
         </a:solidFill>
         <a:effectLst/>
       </p:bgPr>
@@ -3408,7 +3407,7 @@
             <a:avLst/>
           </a:prstGeom>
           <a:solidFill>
-            <a:srgbClr val="0D1B2A"/>
+            <a:srgbClr val="1F2A37"/>
           </a:solidFill>
           <a:ln>
             <a:noFill/>
@@ -3496,7 +3495,7 @@
             <a:r>
               <a:rPr sz="1600" b="0" i="0">
                 <a:solidFill>
-                  <a:srgbClr val="00B4D8"/>
+                  <a:srgbClr val="047857"/>
                 </a:solidFill>
               </a:rPr>
               <a:t>Land in regulated engineering teams, expand across the organisation, grow vertically</a:t>
@@ -3519,7 +3518,7 @@
             <a:avLst/>
           </a:prstGeom>
           <a:solidFill>
-            <a:srgbClr val="0D1B2A"/>
+            <a:srgbClr val="1F2A37"/>
           </a:solidFill>
           <a:ln>
             <a:noFill/>
@@ -3630,7 +3629,7 @@
             <a:avLst/>
           </a:prstGeom>
           <a:solidFill>
-            <a:srgbClr val="0078D4"/>
+            <a:srgbClr val="10B981"/>
           </a:solidFill>
           <a:ln>
             <a:noFill/>
@@ -3741,7 +3740,7 @@
             <a:avLst/>
           </a:prstGeom>
           <a:solidFill>
-            <a:srgbClr val="00B4D8"/>
+            <a:srgbClr val="047857"/>
           </a:solidFill>
           <a:ln>
             <a:noFill/>
@@ -3852,7 +3851,7 @@
             <a:avLst/>
           </a:prstGeom>
           <a:solidFill>
-            <a:srgbClr val="0D1B2A"/>
+            <a:srgbClr val="1F2A37"/>
           </a:solidFill>
           <a:ln>
             <a:noFill/>
@@ -3906,10 +3905,10 @@
             <a:r>
               <a:rPr sz="900" b="0" i="0">
                 <a:solidFill>
-                  <a:srgbClr val="647487"/>
-                </a:solidFill>
-              </a:rPr>
-              <a:t>SAGE[ai] — Open Source (Apache 2.0) | github.com/Sumanharapanahalli/sage | March 2026</a:t>
+                  <a:srgbClr val="4B5563"/>
+                </a:solidFill>
+              </a:rPr>
+              <a:t>SAGE[ai] — Open Source (MIT) | github.com/Sumanharapanahalli/sage | March 2026</a:t>
             </a:r>
           </a:p>
         </p:txBody>
@@ -3928,7 +3927,7 @@
     <p:bg>
       <p:bgPr>
         <a:solidFill>
-          <a:srgbClr val="FFFFFF"/>
+          <a:srgbClr val="FAFAFA"/>
         </a:solidFill>
         <a:effectLst/>
       </p:bgPr>
@@ -3955,7 +3954,7 @@
             <a:avLst/>
           </a:prstGeom>
           <a:solidFill>
-            <a:srgbClr val="ECFDF5"/>
+            <a:srgbClr val="1F2A37"/>
           </a:solidFill>
           <a:ln>
             <a:noFill/>
@@ -4009,7 +4008,7 @@
             <a:r>
               <a:rPr sz="3000" b="1" i="0">
                 <a:solidFill>
-                  <a:srgbClr val="065F46"/>
+                  <a:srgbClr val="FFFFFF"/>
                 </a:solidFill>
               </a:rPr>
               <a:t>Traction — Platform Complete, Pilots Underway</a:t>
@@ -4043,7 +4042,7 @@
             <a:r>
               <a:rPr sz="1600" b="0" i="0">
                 <a:solidFill>
-                  <a:srgbClr val="4B5563"/>
+                  <a:srgbClr val="047857"/>
                 </a:solidFill>
               </a:rPr>
               <a:t>12 integration phases shipped, test suite green, first regulated deployment in progress</a:t>
@@ -4066,7 +4065,7 @@
             <a:avLst/>
           </a:prstGeom>
           <a:solidFill>
-            <a:srgbClr val="ECFDF5"/>
+            <a:srgbClr val="1F2A37"/>
           </a:solidFill>
           <a:ln>
             <a:noFill/>
@@ -4120,7 +4119,7 @@
             <a:r>
               <a:rPr sz="4400" b="1" i="0">
                 <a:solidFill>
-                  <a:srgbClr val="065F46"/>
+                  <a:srgbClr val="FFFFFF"/>
                 </a:solidFill>
               </a:rPr>
               <a:t>136</a:t>
@@ -4154,7 +4153,7 @@
             <a:r>
               <a:rPr sz="1300" b="1" i="0">
                 <a:solidFill>
-                  <a:srgbClr val="065F46"/>
+                  <a:srgbClr val="FFFFFF"/>
                 </a:solidFill>
               </a:rPr>
               <a:t>API endpoints across 22 categories</a:t>
@@ -4188,7 +4187,7 @@
             <a:r>
               <a:rPr sz="1100" b="0" i="1">
                 <a:solidFill>
-                  <a:srgbClr val="F0F4F8"/>
+                  <a:srgbClr val="FAFAFA"/>
                 </a:solidFill>
               </a:rPr>
               <a:t>27 UI pages, 17+ solution templates</a:t>
@@ -4265,7 +4264,7 @@
             <a:r>
               <a:rPr sz="4400" b="1" i="0">
                 <a:solidFill>
-                  <a:srgbClr val="065F46"/>
+                  <a:srgbClr val="FFFFFF"/>
                 </a:solidFill>
               </a:rPr>
               <a:t>79</a:t>
@@ -4299,7 +4298,7 @@
             <a:r>
               <a:rPr sz="1300" b="1" i="0">
                 <a:solidFill>
-                  <a:srgbClr val="065F46"/>
+                  <a:srgbClr val="FFFFFF"/>
                 </a:solidFill>
               </a:rPr>
               <a:t>E2E browser tests (78 passing)</a:t>
@@ -4333,7 +4332,7 @@
             <a:r>
               <a:rPr sz="1100" b="0" i="1">
                 <a:solidFill>
-                  <a:srgbClr val="F0F4F8"/>
+                  <a:srgbClr val="FAFAFA"/>
                 </a:solidFill>
               </a:rPr>
               <a:t>53 test files, full API lifecycle coverage</a:t>
@@ -4356,7 +4355,7 @@
             <a:avLst/>
           </a:prstGeom>
           <a:solidFill>
-            <a:srgbClr val="00B4D8"/>
+            <a:srgbClr val="047857"/>
           </a:solidFill>
           <a:ln>
             <a:noFill/>
@@ -4410,7 +4409,7 @@
             <a:r>
               <a:rPr sz="4400" b="1" i="0">
                 <a:solidFill>
-                  <a:srgbClr val="065F46"/>
+                  <a:srgbClr val="FFFFFF"/>
                 </a:solidFill>
               </a:rPr>
               <a:t>5</a:t>
@@ -4444,7 +4443,7 @@
             <a:r>
               <a:rPr sz="1300" b="1" i="0">
                 <a:solidFill>
-                  <a:srgbClr val="065F46"/>
+                  <a:srgbClr val="FFFFFF"/>
                 </a:solidFill>
               </a:rPr>
               <a:t>LLM providers — zero API keys</a:t>
@@ -4478,10 +4477,10 @@
             <a:r>
               <a:rPr sz="1100" b="0" i="1">
                 <a:solidFill>
-                  <a:srgbClr val="F0F4F8"/>
-                </a:solidFill>
-              </a:rPr>
-              <a:t>Open source Apache 2.0 on GitHub</a:t>
+                  <a:srgbClr val="FAFAFA"/>
+                </a:solidFill>
+              </a:rPr>
+              <a:t>Open source MIT on GitHub</a:t>
             </a:r>
           </a:p>
         </p:txBody>
@@ -4512,10 +4511,10 @@
             <a:r>
               <a:rPr sz="1300" b="0" i="0">
                 <a:solidFill>
-                  <a:srgbClr val="0D1B2A"/>
-                </a:solidFill>
-              </a:rPr>
-              <a:t>Open source release: Apache 2.0 on GitHub — 136 endpoints, 27 pages, 17+ solution templates</a:t>
+                  <a:srgbClr val="1F2A37"/>
+                </a:solidFill>
+              </a:rPr>
+              <a:t>Open source release: MIT on GitHub — 136 endpoints, 27 pages, 17+ solution templates</a:t>
             </a:r>
           </a:p>
         </p:txBody>
@@ -4546,7 +4545,7 @@
             <a:r>
               <a:rPr sz="1300" b="0" i="0">
                 <a:solidFill>
-                  <a:srgbClr val="0D1B2A"/>
+                  <a:srgbClr val="1F2A37"/>
                 </a:solidFill>
               </a:rPr>
               <a:t>12 integrations live: SSE streaming, onboarding wizard, Slack, LangGraph, Temporal, eval, multi-tenant</a:t>
@@ -4580,7 +4579,7 @@
             <a:r>
               <a:rPr sz="1300" b="0" i="0">
                 <a:solidFill>
-                  <a:srgbClr val="0D1B2A"/>
+                  <a:srgbClr val="1F2A37"/>
                 </a:solidFill>
               </a:rPr>
               <a:t>Build Orchestrator: 13 domain detection, 19 agents, 5 teams, Q-learning adaptive router</a:t>
@@ -4614,7 +4613,7 @@
             <a:r>
               <a:rPr sz="1300" b="0" i="0">
                 <a:solidFill>
-                  <a:srgbClr val="0D1B2A"/>
+                  <a:srgbClr val="1F2A37"/>
                 </a:solidFill>
               </a:rPr>
               <a:t>Community-driven: framework is public, proprietary solutions mounted via SAGE_SOLUTIONS_DIR</a:t>
@@ -4637,7 +4636,7 @@
             <a:avLst/>
           </a:prstGeom>
           <a:solidFill>
-            <a:srgbClr val="ECFDF5"/>
+            <a:srgbClr val="1F2A37"/>
           </a:solidFill>
           <a:ln>
             <a:noFill/>
@@ -4691,10 +4690,10 @@
             <a:r>
               <a:rPr sz="900" b="0" i="0">
                 <a:solidFill>
-                  <a:srgbClr val="6B7280"/>
-                </a:solidFill>
-              </a:rPr>
-              <a:t>SAGE[ai] — Open Source (Apache 2.0) | github.com/Sumanharapanahalli/sage | March 2026</a:t>
+                  <a:srgbClr val="4B5563"/>
+                </a:solidFill>
+              </a:rPr>
+              <a:t>SAGE[ai] — Open Source (MIT) | github.com/Sumanharapanahalli/sage | March 2026</a:t>
             </a:r>
           </a:p>
         </p:txBody>
@@ -4713,7 +4712,7 @@
     <p:bg>
       <p:bgPr>
         <a:solidFill>
-          <a:srgbClr val="F0F4F8"/>
+          <a:srgbClr val="FAFAFA"/>
         </a:solidFill>
         <a:effectLst/>
       </p:bgPr>
@@ -4740,7 +4739,7 @@
             <a:avLst/>
           </a:prstGeom>
           <a:solidFill>
-            <a:srgbClr val="0D1B2A"/>
+            <a:srgbClr val="1F2A37"/>
           </a:solidFill>
           <a:ln>
             <a:noFill/>
@@ -4828,7 +4827,7 @@
             <a:r>
               <a:rPr sz="1600" b="0" i="0">
                 <a:solidFill>
-                  <a:srgbClr val="00B4D8"/>
+                  <a:srgbClr val="047857"/>
                 </a:solidFill>
               </a:rPr>
               <a:t>Conservative estimates based on industry benchmarks — all figures assumption-based*</a:t>
@@ -4879,7 +4878,7 @@
                   </a:txBody>
                   <a:tcPr>
                     <a:solidFill>
-                      <a:srgbClr val="0078D4"/>
+                      <a:srgbClr val="10B981"/>
                     </a:solidFill>
                   </a:tcPr>
                 </a:tc>
@@ -4901,7 +4900,7 @@
                   </a:txBody>
                   <a:tcPr>
                     <a:solidFill>
-                      <a:srgbClr val="0078D4"/>
+                      <a:srgbClr val="10B981"/>
                     </a:solidFill>
                   </a:tcPr>
                 </a:tc>
@@ -4923,7 +4922,7 @@
                   </a:txBody>
                   <a:tcPr>
                     <a:solidFill>
-                      <a:srgbClr val="0078D4"/>
+                      <a:srgbClr val="10B981"/>
                     </a:solidFill>
                   </a:tcPr>
                 </a:tc>
@@ -4945,7 +4944,7 @@
                   </a:txBody>
                   <a:tcPr>
                     <a:solidFill>
-                      <a:srgbClr val="0078D4"/>
+                      <a:srgbClr val="10B981"/>
                     </a:solidFill>
                   </a:tcPr>
                 </a:tc>
@@ -4960,7 +4959,7 @@
                       <a:r>
                         <a:rPr sz="1200">
                           <a:solidFill>
-                            <a:srgbClr val="0D1B2A"/>
+                            <a:srgbClr val="1F2A37"/>
                           </a:solidFill>
                         </a:rPr>
                         <a:t>Customers (deployments)</a:t>
@@ -4969,7 +4968,7 @@
                   </a:txBody>
                   <a:tcPr>
                     <a:solidFill>
-                      <a:srgbClr val="F0F4F8"/>
+                      <a:srgbClr val="FAFAFA"/>
                     </a:solidFill>
                   </a:tcPr>
                 </a:tc>
@@ -4982,7 +4981,7 @@
                       <a:r>
                         <a:rPr sz="1200">
                           <a:solidFill>
-                            <a:srgbClr val="0D1B2A"/>
+                            <a:srgbClr val="1F2A37"/>
                           </a:solidFill>
                         </a:rPr>
                         <a:t>3-5 pilots</a:t>
@@ -4991,7 +4990,7 @@
                   </a:txBody>
                   <a:tcPr>
                     <a:solidFill>
-                      <a:srgbClr val="F0F4F8"/>
+                      <a:srgbClr val="FAFAFA"/>
                     </a:solidFill>
                   </a:tcPr>
                 </a:tc>
@@ -5004,7 +5003,7 @@
                       <a:r>
                         <a:rPr sz="1200">
                           <a:solidFill>
-                            <a:srgbClr val="0D1B2A"/>
+                            <a:srgbClr val="1F2A37"/>
                           </a:solidFill>
                         </a:rPr>
                         <a:t>15-25</a:t>
@@ -5013,7 +5012,7 @@
                   </a:txBody>
                   <a:tcPr>
                     <a:solidFill>
-                      <a:srgbClr val="F0F4F8"/>
+                      <a:srgbClr val="FAFAFA"/>
                     </a:solidFill>
                   </a:tcPr>
                 </a:tc>
@@ -5026,7 +5025,7 @@
                       <a:r>
                         <a:rPr sz="1200">
                           <a:solidFill>
-                            <a:srgbClr val="0D1B2A"/>
+                            <a:srgbClr val="1F2A37"/>
                           </a:solidFill>
                         </a:rPr>
                         <a:t>50-80</a:t>
@@ -5035,7 +5034,7 @@
                   </a:txBody>
                   <a:tcPr>
                     <a:solidFill>
-                      <a:srgbClr val="F0F4F8"/>
+                      <a:srgbClr val="FAFAFA"/>
                     </a:solidFill>
                   </a:tcPr>
                 </a:tc>
@@ -5050,7 +5049,7 @@
                       <a:r>
                         <a:rPr sz="1200">
                           <a:solidFill>
-                            <a:srgbClr val="0D1B2A"/>
+                            <a:srgbClr val="1F2A37"/>
                           </a:solidFill>
                         </a:rPr>
                         <a:t>Average Contract Value</a:t>
@@ -5072,7 +5071,7 @@
                       <a:r>
                         <a:rPr sz="1200">
                           <a:solidFill>
-                            <a:srgbClr val="0D1B2A"/>
+                            <a:srgbClr val="1F2A37"/>
                           </a:solidFill>
                         </a:rPr>
                         <a:t>$45K ARR</a:t>
@@ -5094,7 +5093,7 @@
                       <a:r>
                         <a:rPr sz="1200">
                           <a:solidFill>
-                            <a:srgbClr val="0D1B2A"/>
+                            <a:srgbClr val="1F2A37"/>
                           </a:solidFill>
                         </a:rPr>
                         <a:t>$65K ARR</a:t>
@@ -5116,7 +5115,7 @@
                       <a:r>
                         <a:rPr sz="1200">
                           <a:solidFill>
-                            <a:srgbClr val="0D1B2A"/>
+                            <a:srgbClr val="1F2A37"/>
                           </a:solidFill>
                         </a:rPr>
                         <a:t>$85K ARR</a:t>
@@ -5140,7 +5139,7 @@
                       <a:r>
                         <a:rPr sz="1200">
                           <a:solidFill>
-                            <a:srgbClr val="0D1B2A"/>
+                            <a:srgbClr val="1F2A37"/>
                           </a:solidFill>
                         </a:rPr>
                         <a:t>Annual Recurring Revenue</a:t>
@@ -5149,7 +5148,7 @@
                   </a:txBody>
                   <a:tcPr>
                     <a:solidFill>
-                      <a:srgbClr val="F0F4F8"/>
+                      <a:srgbClr val="FAFAFA"/>
                     </a:solidFill>
                   </a:tcPr>
                 </a:tc>
@@ -5162,7 +5161,7 @@
                       <a:r>
                         <a:rPr sz="1200">
                           <a:solidFill>
-                            <a:srgbClr val="0D1B2A"/>
+                            <a:srgbClr val="1F2A37"/>
                           </a:solidFill>
                         </a:rPr>
                         <a:t>$180K</a:t>
@@ -5171,7 +5170,7 @@
                   </a:txBody>
                   <a:tcPr>
                     <a:solidFill>
-                      <a:srgbClr val="F0F4F8"/>
+                      <a:srgbClr val="FAFAFA"/>
                     </a:solidFill>
                   </a:tcPr>
                 </a:tc>
@@ -5184,7 +5183,7 @@
                       <a:r>
                         <a:rPr sz="1200">
                           <a:solidFill>
-                            <a:srgbClr val="0D1B2A"/>
+                            <a:srgbClr val="1F2A37"/>
                           </a:solidFill>
                         </a:rPr>
                         <a:t>$1.3M</a:t>
@@ -5193,7 +5192,7 @@
                   </a:txBody>
                   <a:tcPr>
                     <a:solidFill>
-                      <a:srgbClr val="F0F4F8"/>
+                      <a:srgbClr val="FAFAFA"/>
                     </a:solidFill>
                   </a:tcPr>
                 </a:tc>
@@ -5206,7 +5205,7 @@
                       <a:r>
                         <a:rPr sz="1200">
                           <a:solidFill>
-                            <a:srgbClr val="0D1B2A"/>
+                            <a:srgbClr val="1F2A37"/>
                           </a:solidFill>
                         </a:rPr>
                         <a:t>$5.5M</a:t>
@@ -5215,7 +5214,7 @@
                   </a:txBody>
                   <a:tcPr>
                     <a:solidFill>
-                      <a:srgbClr val="F0F4F8"/>
+                      <a:srgbClr val="FAFAFA"/>
                     </a:solidFill>
                   </a:tcPr>
                 </a:tc>
@@ -5230,7 +5229,7 @@
                       <a:r>
                         <a:rPr sz="1200">
                           <a:solidFill>
-                            <a:srgbClr val="0D1B2A"/>
+                            <a:srgbClr val="1F2A37"/>
                           </a:solidFill>
                         </a:rPr>
                         <a:t>Professional Services</a:t>
@@ -5252,7 +5251,7 @@
                       <a:r>
                         <a:rPr sz="1200">
                           <a:solidFill>
-                            <a:srgbClr val="0D1B2A"/>
+                            <a:srgbClr val="1F2A37"/>
                           </a:solidFill>
                         </a:rPr>
                         <a:t>$150K</a:t>
@@ -5274,7 +5273,7 @@
                       <a:r>
                         <a:rPr sz="1200">
                           <a:solidFill>
-                            <a:srgbClr val="0D1B2A"/>
+                            <a:srgbClr val="1F2A37"/>
                           </a:solidFill>
                         </a:rPr>
                         <a:t>$400K</a:t>
@@ -5296,7 +5295,7 @@
                       <a:r>
                         <a:rPr sz="1200">
                           <a:solidFill>
-                            <a:srgbClr val="0D1B2A"/>
+                            <a:srgbClr val="1F2A37"/>
                           </a:solidFill>
                         </a:rPr>
                         <a:t>$800K</a:t>
@@ -5320,7 +5319,7 @@
                       <a:r>
                         <a:rPr sz="1200">
                           <a:solidFill>
-                            <a:srgbClr val="0D1B2A"/>
+                            <a:srgbClr val="1F2A37"/>
                           </a:solidFill>
                         </a:rPr>
                         <a:t>Total Revenue</a:t>
@@ -5329,7 +5328,7 @@
                   </a:txBody>
                   <a:tcPr>
                     <a:solidFill>
-                      <a:srgbClr val="F0F4F8"/>
+                      <a:srgbClr val="FAFAFA"/>
                     </a:solidFill>
                   </a:tcPr>
                 </a:tc>
@@ -5342,7 +5341,7 @@
                       <a:r>
                         <a:rPr sz="1200">
                           <a:solidFill>
-                            <a:srgbClr val="0D1B2A"/>
+                            <a:srgbClr val="1F2A37"/>
                           </a:solidFill>
                         </a:rPr>
                         <a:t>$330K</a:t>
@@ -5351,7 +5350,7 @@
                   </a:txBody>
                   <a:tcPr>
                     <a:solidFill>
-                      <a:srgbClr val="F0F4F8"/>
+                      <a:srgbClr val="FAFAFA"/>
                     </a:solidFill>
                   </a:tcPr>
                 </a:tc>
@@ -5364,7 +5363,7 @@
                       <a:r>
                         <a:rPr sz="1200">
                           <a:solidFill>
-                            <a:srgbClr val="0D1B2A"/>
+                            <a:srgbClr val="1F2A37"/>
                           </a:solidFill>
                         </a:rPr>
                         <a:t>$1.7M</a:t>
@@ -5373,7 +5372,7 @@
                   </a:txBody>
                   <a:tcPr>
                     <a:solidFill>
-                      <a:srgbClr val="F0F4F8"/>
+                      <a:srgbClr val="FAFAFA"/>
                     </a:solidFill>
                   </a:tcPr>
                 </a:tc>
@@ -5386,7 +5385,7 @@
                       <a:r>
                         <a:rPr sz="1200">
                           <a:solidFill>
-                            <a:srgbClr val="0D1B2A"/>
+                            <a:srgbClr val="1F2A37"/>
                           </a:solidFill>
                         </a:rPr>
                         <a:t>$6.3M</a:t>
@@ -5395,7 +5394,7 @@
                   </a:txBody>
                   <a:tcPr>
                     <a:solidFill>
-                      <a:srgbClr val="F0F4F8"/>
+                      <a:srgbClr val="FAFAFA"/>
                     </a:solidFill>
                   </a:tcPr>
                 </a:tc>
@@ -5410,7 +5409,7 @@
                       <a:r>
                         <a:rPr sz="1200">
                           <a:solidFill>
-                            <a:srgbClr val="0D1B2A"/>
+                            <a:srgbClr val="1F2A37"/>
                           </a:solidFill>
                         </a:rPr>
                         <a:t>Gross Margin (blended)</a:t>
@@ -5432,7 +5431,7 @@
                       <a:r>
                         <a:rPr sz="1200">
                           <a:solidFill>
-                            <a:srgbClr val="0D1B2A"/>
+                            <a:srgbClr val="1F2A37"/>
                           </a:solidFill>
                         </a:rPr>
                         <a:t>55%</a:t>
@@ -5454,7 +5453,7 @@
                       <a:r>
                         <a:rPr sz="1200">
                           <a:solidFill>
-                            <a:srgbClr val="0D1B2A"/>
+                            <a:srgbClr val="1F2A37"/>
                           </a:solidFill>
                         </a:rPr>
                         <a:t>62%</a:t>
@@ -5476,7 +5475,7 @@
                       <a:r>
                         <a:rPr sz="1200">
                           <a:solidFill>
-                            <a:srgbClr val="0D1B2A"/>
+                            <a:srgbClr val="1F2A37"/>
                           </a:solidFill>
                         </a:rPr>
                         <a:t>68%</a:t>
@@ -5500,7 +5499,7 @@
                       <a:r>
                         <a:rPr sz="1200">
                           <a:solidFill>
-                            <a:srgbClr val="0D1B2A"/>
+                            <a:srgbClr val="1F2A37"/>
                           </a:solidFill>
                         </a:rPr>
                         <a:t>Headcount</a:t>
@@ -5509,7 +5508,7 @@
                   </a:txBody>
                   <a:tcPr>
                     <a:solidFill>
-                      <a:srgbClr val="F0F4F8"/>
+                      <a:srgbClr val="FAFAFA"/>
                     </a:solidFill>
                   </a:tcPr>
                 </a:tc>
@@ -5522,7 +5521,7 @@
                       <a:r>
                         <a:rPr sz="1200">
                           <a:solidFill>
-                            <a:srgbClr val="0D1B2A"/>
+                            <a:srgbClr val="1F2A37"/>
                           </a:solidFill>
                         </a:rPr>
                         <a:t>4</a:t>
@@ -5531,7 +5530,7 @@
                   </a:txBody>
                   <a:tcPr>
                     <a:solidFill>
-                      <a:srgbClr val="F0F4F8"/>
+                      <a:srgbClr val="FAFAFA"/>
                     </a:solidFill>
                   </a:tcPr>
                 </a:tc>
@@ -5544,7 +5543,7 @@
                       <a:r>
                         <a:rPr sz="1200">
                           <a:solidFill>
-                            <a:srgbClr val="0D1B2A"/>
+                            <a:srgbClr val="1F2A37"/>
                           </a:solidFill>
                         </a:rPr>
                         <a:t>12</a:t>
@@ -5553,7 +5552,7 @@
                   </a:txBody>
                   <a:tcPr>
                     <a:solidFill>
-                      <a:srgbClr val="F0F4F8"/>
+                      <a:srgbClr val="FAFAFA"/>
                     </a:solidFill>
                   </a:tcPr>
                 </a:tc>
@@ -5566,7 +5565,7 @@
                       <a:r>
                         <a:rPr sz="1200">
                           <a:solidFill>
-                            <a:srgbClr val="0D1B2A"/>
+                            <a:srgbClr val="1F2A37"/>
                           </a:solidFill>
                         </a:rPr>
                         <a:t>25</a:t>
@@ -5575,7 +5574,7 @@
                   </a:txBody>
                   <a:tcPr>
                     <a:solidFill>
-                      <a:srgbClr val="F0F4F8"/>
+                      <a:srgbClr val="FAFAFA"/>
                     </a:solidFill>
                   </a:tcPr>
                 </a:tc>
@@ -5610,7 +5609,7 @@
             <a:r>
               <a:rPr sz="1100" b="0" i="1">
                 <a:solidFill>
-                  <a:srgbClr val="647487"/>
+                  <a:srgbClr val="4B5563"/>
                 </a:solidFill>
               </a:rPr>
               <a:t>* All projections are assumption-based. Replace with validated data before any investment decision.</a:t>
@@ -5633,7 +5632,7 @@
             <a:avLst/>
           </a:prstGeom>
           <a:solidFill>
-            <a:srgbClr val="0D1B2A"/>
+            <a:srgbClr val="1F2A37"/>
           </a:solidFill>
           <a:ln>
             <a:noFill/>
@@ -5687,10 +5686,10 @@
             <a:r>
               <a:rPr sz="900" b="0" i="0">
                 <a:solidFill>
-                  <a:srgbClr val="647487"/>
-                </a:solidFill>
-              </a:rPr>
-              <a:t>SAGE[ai] — Open Source (Apache 2.0) | github.com/Sumanharapanahalli/sage | March 2026</a:t>
+                  <a:srgbClr val="4B5563"/>
+                </a:solidFill>
+              </a:rPr>
+              <a:t>SAGE[ai] — Open Source (MIT) | github.com/Sumanharapanahalli/sage | March 2026</a:t>
             </a:r>
           </a:p>
         </p:txBody>
@@ -5786,7 +5785,7 @@
     <p:bg>
       <p:bgPr>
         <a:solidFill>
-          <a:srgbClr val="F0F4F8"/>
+          <a:srgbClr val="FAFAFA"/>
         </a:solidFill>
         <a:effectLst/>
       </p:bgPr>
@@ -5813,7 +5812,7 @@
             <a:avLst/>
           </a:prstGeom>
           <a:solidFill>
-            <a:srgbClr val="0D1B2A"/>
+            <a:srgbClr val="1F2A37"/>
           </a:solidFill>
           <a:ln>
             <a:noFill/>
@@ -5901,7 +5900,7 @@
             <a:r>
               <a:rPr sz="1600" b="0" i="0">
                 <a:solidFill>
-                  <a:srgbClr val="00B4D8"/>
+                  <a:srgbClr val="047857"/>
                 </a:solidFill>
               </a:rPr>
               <a:t>18-month runway to first significant revenue and an enterprise customer base</a:t>
@@ -5924,7 +5923,7 @@
             <a:avLst/>
           </a:prstGeom>
           <a:solidFill>
-            <a:srgbClr val="0D1B2A"/>
+            <a:srgbClr val="1F2A37"/>
           </a:solidFill>
           <a:ln>
             <a:noFill/>
@@ -6012,7 +6011,7 @@
             <a:r>
               <a:rPr sz="1200" b="0" i="1">
                 <a:solidFill>
-                  <a:srgbClr val="00B4D8"/>
+                  <a:srgbClr val="047857"/>
                 </a:solidFill>
               </a:rPr>
               <a:t>How the capital is deployed</a:t>
@@ -6171,7 +6170,7 @@
             <a:avLst/>
           </a:prstGeom>
           <a:solidFill>
-            <a:srgbClr val="0078D4"/>
+            <a:srgbClr val="10B981"/>
           </a:solidFill>
           <a:ln>
             <a:noFill/>
@@ -6259,7 +6258,7 @@
             <a:r>
               <a:rPr sz="1200" b="0" i="1">
                 <a:solidFill>
-                  <a:srgbClr val="00B4D8"/>
+                  <a:srgbClr val="047857"/>
                 </a:solidFill>
               </a:rPr>
               <a:t>What the investment delivers</a:t>
@@ -6463,7 +6462,7 @@
             <a:r>
               <a:rPr sz="1000" b="0" i="1">
                 <a:solidFill>
-                  <a:srgbClr val="647487"/>
+                  <a:srgbClr val="4B5563"/>
                 </a:solidFill>
               </a:rPr>
               <a:t>All financial projections are assumptions — validate before any investment decision.</a:t>
@@ -6486,7 +6485,7 @@
             <a:avLst/>
           </a:prstGeom>
           <a:solidFill>
-            <a:srgbClr val="0D1B2A"/>
+            <a:srgbClr val="1F2A37"/>
           </a:solidFill>
           <a:ln>
             <a:noFill/>
@@ -6540,10 +6539,10 @@
             <a:r>
               <a:rPr sz="900" b="0" i="0">
                 <a:solidFill>
-                  <a:srgbClr val="647487"/>
-                </a:solidFill>
-              </a:rPr>
-              <a:t>SAGE[ai] — Open Source (Apache 2.0) | github.com/Sumanharapanahalli/sage | March 2026</a:t>
+                  <a:srgbClr val="4B5563"/>
+                </a:solidFill>
+              </a:rPr>
+              <a:t>SAGE[ai] — Open Source (MIT) | github.com/Sumanharapanahalli/sage | March 2026</a:t>
             </a:r>
           </a:p>
         </p:txBody>
@@ -6636,14 +6635,6 @@
 <file path=ppt/slides/slide14.xml><?xml version="1.0" encoding="utf-8"?>
 <p:sld xmlns:a="http://schemas.openxmlformats.org/drawingml/2006/main" xmlns:p="http://schemas.openxmlformats.org/presentationml/2006/main" xmlns:r="http://schemas.openxmlformats.org/officeDocument/2006/relationships">
   <p:cSld>
-    <p:bg>
-      <p:bgPr>
-        <a:solidFill>
-          <a:srgbClr val="FFFFFF"/>
-        </a:solidFill>
-        <a:effectLst/>
-      </p:bgPr>
-    </p:bg>
     <p:spTree>
       <p:nvGrpSpPr>
         <p:cNvPr id="1" name=""/>
@@ -6660,13 +6651,13 @@
         <p:spPr>
           <a:xfrm>
             <a:off x="0" y="0"/>
-            <a:ext cx="12188952" cy="1325880"/>
+            <a:ext cx="12188952" cy="6858000"/>
           </a:xfrm>
           <a:prstGeom prst="rect">
             <a:avLst/>
           </a:prstGeom>
           <a:solidFill>
-            <a:srgbClr val="ECFDF5"/>
+            <a:srgbClr val="1F2A37"/>
           </a:solidFill>
           <a:ln>
             <a:noFill/>
@@ -6696,249 +6687,20 @@
       </p:sp>
       <p:sp>
         <p:nvSpPr>
-          <p:cNvPr id="3" name="TextBox 2"/>
-          <p:cNvSpPr txBox="1"/>
-          <p:nvPr/>
-        </p:nvSpPr>
-        <p:spPr>
-          <a:xfrm>
-            <a:off x="411480" y="109728"/>
-            <a:ext cx="11338560" cy="731520"/>
-          </a:xfrm>
-          <a:prstGeom prst="rect">
-            <a:avLst/>
-          </a:prstGeom>
-          <a:noFill/>
-        </p:spPr>
-        <p:txBody>
-          <a:bodyPr wrap="none">
-            <a:spAutoFit/>
-          </a:bodyPr>
-          <a:lstStyle/>
-          <a:p>
-            <a:r>
-              <a:rPr sz="3000" b="1">
-                <a:solidFill>
-                  <a:srgbClr val="065F46"/>
-                </a:solidFill>
-                <a:latin typeface="Calibri"/>
-              </a:rPr>
-              <a:t>Build Orchestrator — The Meta-Agent Factory</a:t>
-            </a:r>
-          </a:p>
-        </p:txBody>
-      </p:sp>
-      <p:sp>
-        <p:nvSpPr>
-          <p:cNvPr id="4" name="TextBox 3"/>
-          <p:cNvSpPr txBox="1"/>
-          <p:nvPr/>
-        </p:nvSpPr>
-        <p:spPr>
-          <a:xfrm>
-            <a:off x="411480" y="804672"/>
-            <a:ext cx="11338560" cy="438912"/>
-          </a:xfrm>
-          <a:prstGeom prst="rect">
-            <a:avLst/>
-          </a:prstGeom>
-          <a:noFill/>
-        </p:spPr>
-        <p:txBody>
-          <a:bodyPr wrap="none">
-            <a:spAutoFit/>
-          </a:bodyPr>
-          <a:lstStyle/>
-          <a:p>
-            <a:r>
-              <a:rPr sz="1600" b="0">
-                <a:solidFill>
-                  <a:srgbClr val="4B5563"/>
-                </a:solidFill>
-                <a:latin typeface="Calibri"/>
-              </a:rPr>
-              <a:t>SAGE doesn’t just assist development — it builds entire products autonomously</a:t>
-            </a:r>
-          </a:p>
-        </p:txBody>
-      </p:sp>
-      <p:sp>
-        <p:nvSpPr>
-          <p:cNvPr id="5" name="TextBox 4"/>
-          <p:cNvSpPr txBox="1"/>
-          <p:nvPr/>
-        </p:nvSpPr>
-        <p:spPr>
-          <a:xfrm>
-            <a:off x="457200" y="1508760"/>
-            <a:ext cx="11247120" cy="457200"/>
-          </a:xfrm>
-          <a:prstGeom prst="rect">
-            <a:avLst/>
-          </a:prstGeom>
-          <a:noFill/>
-        </p:spPr>
-        <p:txBody>
-          <a:bodyPr wrap="square">
-            <a:spAutoFit/>
-          </a:bodyPr>
-          <a:lstStyle/>
-          <a:p>
-            <a:pPr algn="ctr"/>
-            <a:r>
-              <a:rPr sz="1500" b="1">
-                <a:solidFill>
-                  <a:srgbClr val="059669"/>
-                </a:solidFill>
-                <a:latin typeface="Calibri"/>
-              </a:rPr>
-              <a:t>Idea</a:t>
-            </a:r>
-            <a:r>
-              <a:rPr sz="1500" b="0">
-                <a:solidFill>
-                  <a:srgbClr val="6B7280"/>
-                </a:solidFill>
-                <a:latin typeface="Calibri"/>
-              </a:rPr>
-              <a:t>  →  </a:t>
-            </a:r>
-            <a:r>
-              <a:rPr sz="1500" b="1">
-                <a:solidFill>
-                  <a:srgbClr val="059669"/>
-                </a:solidFill>
-                <a:latin typeface="Calibri"/>
-              </a:rPr>
-              <a:t>Decompose</a:t>
-            </a:r>
-            <a:r>
-              <a:rPr sz="1500" b="0">
-                <a:solidFill>
-                  <a:srgbClr val="6B7280"/>
-                </a:solidFill>
-                <a:latin typeface="Calibri"/>
-              </a:rPr>
-              <a:t>  →  </a:t>
-            </a:r>
-            <a:r>
-              <a:rPr sz="1500" b="1">
-                <a:solidFill>
-                  <a:srgbClr val="059669"/>
-                </a:solidFill>
-                <a:latin typeface="Calibri"/>
-              </a:rPr>
-              <a:t>Critic</a:t>
-            </a:r>
-            <a:r>
-              <a:rPr sz="1500" b="0">
-                <a:solidFill>
-                  <a:srgbClr val="6B7280"/>
-                </a:solidFill>
-                <a:latin typeface="Calibri"/>
-              </a:rPr>
-              <a:t>  →  </a:t>
-            </a:r>
-            <a:r>
-              <a:rPr sz="1500" b="1">
-                <a:solidFill>
-                  <a:srgbClr val="059669"/>
-                </a:solidFill>
-                <a:latin typeface="Calibri"/>
-              </a:rPr>
-              <a:t>Approve</a:t>
-            </a:r>
-            <a:r>
-              <a:rPr sz="1500" b="0">
-                <a:solidFill>
-                  <a:srgbClr val="6B7280"/>
-                </a:solidFill>
-                <a:latin typeface="Calibri"/>
-              </a:rPr>
-              <a:t>  →  </a:t>
-            </a:r>
-            <a:r>
-              <a:rPr sz="1500" b="1">
-                <a:solidFill>
-                  <a:srgbClr val="059669"/>
-                </a:solidFill>
-                <a:latin typeface="Calibri"/>
-              </a:rPr>
-              <a:t>Build</a:t>
-            </a:r>
-            <a:r>
-              <a:rPr sz="1500" b="0">
-                <a:solidFill>
-                  <a:srgbClr val="6B7280"/>
-                </a:solidFill>
-                <a:latin typeface="Calibri"/>
-              </a:rPr>
-              <a:t>  →  </a:t>
-            </a:r>
-            <a:r>
-              <a:rPr sz="1500" b="1">
-                <a:solidFill>
-                  <a:srgbClr val="059669"/>
-                </a:solidFill>
-                <a:latin typeface="Calibri"/>
-              </a:rPr>
-              <a:t>Critic</a:t>
-            </a:r>
-            <a:r>
-              <a:rPr sz="1500" b="0">
-                <a:solidFill>
-                  <a:srgbClr val="6B7280"/>
-                </a:solidFill>
-                <a:latin typeface="Calibri"/>
-              </a:rPr>
-              <a:t>  →  </a:t>
-            </a:r>
-            <a:r>
-              <a:rPr sz="1500" b="1">
-                <a:solidFill>
-                  <a:srgbClr val="059669"/>
-                </a:solidFill>
-                <a:latin typeface="Calibri"/>
-              </a:rPr>
-              <a:t>Approve</a:t>
-            </a:r>
-            <a:r>
-              <a:rPr sz="1500" b="0">
-                <a:solidFill>
-                  <a:srgbClr val="6B7280"/>
-                </a:solidFill>
-                <a:latin typeface="Calibri"/>
-              </a:rPr>
-              <a:t>  →  </a:t>
-            </a:r>
-            <a:r>
-              <a:rPr sz="1500" b="1">
-                <a:solidFill>
-                  <a:srgbClr val="059669"/>
-                </a:solidFill>
-                <a:latin typeface="Calibri"/>
-              </a:rPr>
-              <a:t>Ship</a:t>
-            </a:r>
-          </a:p>
-        </p:txBody>
-      </p:sp>
-      <p:sp>
-        <p:nvSpPr>
-          <p:cNvPr id="6" name="Rectangle 5"/>
+          <p:cNvPr id="3" name="Rectangle 2"/>
           <p:cNvSpPr/>
           <p:nvPr/>
         </p:nvSpPr>
         <p:spPr>
           <a:xfrm>
-            <a:off x="457200" y="2194560"/>
-            <a:ext cx="3627120" cy="2743200"/>
+            <a:off x="0" y="3749039"/>
+            <a:ext cx="12188952" cy="54864"/>
           </a:xfrm>
           <a:prstGeom prst="rect">
             <a:avLst/>
           </a:prstGeom>
           <a:solidFill>
-            <a:srgbClr val="ECFDF5"/>
+            <a:srgbClr val="047857"/>
           </a:solidFill>
           <a:ln>
             <a:noFill/>
@@ -6968,88 +6730,20 @@
       </p:sp>
       <p:sp>
         <p:nvSpPr>
-          <p:cNvPr id="7" name="TextBox 6"/>
-          <p:cNvSpPr txBox="1"/>
-          <p:nvPr/>
-        </p:nvSpPr>
-        <p:spPr>
-          <a:xfrm>
-            <a:off x="548640" y="2286000"/>
-            <a:ext cx="3444240" cy="274320"/>
-          </a:xfrm>
-          <a:prstGeom prst="rect">
-            <a:avLst/>
-          </a:prstGeom>
-          <a:noFill/>
-        </p:spPr>
-        <p:txBody>
-          <a:bodyPr wrap="none">
-            <a:spAutoFit/>
-          </a:bodyPr>
-          <a:lstStyle/>
-          <a:p>
-            <a:r>
-              <a:rPr sz="1500" b="1">
-                <a:solidFill>
-                  <a:srgbClr val="059669"/>
-                </a:solidFill>
-                <a:latin typeface="Calibri"/>
-              </a:rPr>
-              <a:t>Actor-Critic Pattern</a:t>
-            </a:r>
-          </a:p>
-        </p:txBody>
-      </p:sp>
-      <p:sp>
-        <p:nvSpPr>
-          <p:cNvPr id="8" name="TextBox 7"/>
-          <p:cNvSpPr txBox="1"/>
-          <p:nvPr/>
-        </p:nvSpPr>
-        <p:spPr>
-          <a:xfrm>
-            <a:off x="548640" y="2514600"/>
-            <a:ext cx="3444240" cy="2377440"/>
-          </a:xfrm>
-          <a:prstGeom prst="rect">
-            <a:avLst/>
-          </a:prstGeom>
-          <a:noFill/>
-        </p:spPr>
-        <p:txBody>
-          <a:bodyPr wrap="square">
-            <a:spAutoFit/>
-          </a:bodyPr>
-          <a:lstStyle/>
-          <a:p>
-            <a:r>
-              <a:rPr sz="1300" b="0">
-                <a:solidFill>
-                  <a:srgbClr val="374151"/>
-                </a:solidFill>
-                <a:latin typeface="Calibri"/>
-              </a:rPr>
-              <a:t>Every output stress-tested before humans see it. Score improves across iterations.</a:t>
-            </a:r>
-          </a:p>
-        </p:txBody>
-      </p:sp>
-      <p:sp>
-        <p:nvSpPr>
-          <p:cNvPr id="9" name="Rectangle 8"/>
+          <p:cNvPr id="4" name="Rectangle 3"/>
           <p:cNvSpPr/>
           <p:nvPr/>
         </p:nvSpPr>
         <p:spPr>
           <a:xfrm>
-            <a:off x="4267200" y="2194560"/>
-            <a:ext cx="3627120" cy="2743200"/>
+            <a:off x="0" y="0"/>
+            <a:ext cx="365760" cy="6858000"/>
           </a:xfrm>
           <a:prstGeom prst="rect">
             <a:avLst/>
           </a:prstGeom>
           <a:solidFill>
-            <a:srgbClr val="ECFDF5"/>
+            <a:srgbClr val="10B981"/>
           </a:solidFill>
           <a:ln>
             <a:noFill/>
@@ -7079,443 +6773,6 @@
       </p:sp>
       <p:sp>
         <p:nvSpPr>
-          <p:cNvPr id="10" name="TextBox 9"/>
-          <p:cNvSpPr txBox="1"/>
-          <p:nvPr/>
-        </p:nvSpPr>
-        <p:spPr>
-          <a:xfrm>
-            <a:off x="4358640" y="2286000"/>
-            <a:ext cx="3444240" cy="274320"/>
-          </a:xfrm>
-          <a:prstGeom prst="rect">
-            <a:avLst/>
-          </a:prstGeom>
-          <a:noFill/>
-        </p:spPr>
-        <p:txBody>
-          <a:bodyPr wrap="none">
-            <a:spAutoFit/>
-          </a:bodyPr>
-          <a:lstStyle/>
-          <a:p>
-            <a:r>
-              <a:rPr sz="1500" b="1">
-                <a:solidFill>
-                  <a:srgbClr val="059669"/>
-                </a:solidFill>
-                <a:latin typeface="Calibri"/>
-              </a:rPr>
-              <a:t>10 Agentic Architectures</a:t>
-            </a:r>
-          </a:p>
-        </p:txBody>
-      </p:sp>
-      <p:sp>
-        <p:nvSpPr>
-          <p:cNvPr id="11" name="TextBox 10"/>
-          <p:cNvSpPr txBox="1"/>
-          <p:nvPr/>
-        </p:nvSpPr>
-        <p:spPr>
-          <a:xfrm>
-            <a:off x="4358640" y="2514600"/>
-            <a:ext cx="3444240" cy="2377440"/>
-          </a:xfrm>
-          <a:prstGeom prst="rect">
-            <a:avLst/>
-          </a:prstGeom>
-          <a:noFill/>
-        </p:spPr>
-        <p:txBody>
-          <a:bodyPr wrap="square">
-            <a:spAutoFit/>
-          </a:bodyPr>
-          <a:lstStyle/>
-          <a:p>
-            <a:r>
-              <a:rPr sz="1300" b="0">
-                <a:solidFill>
-                  <a:srgbClr val="374151"/>
-                </a:solidFill>
-                <a:latin typeface="Calibri"/>
-              </a:rPr>
-              <a:t>Built products can use any Google Cloud reference pattern — not just chat bots.</a:t>
-            </a:r>
-          </a:p>
-        </p:txBody>
-      </p:sp>
-      <p:sp>
-        <p:nvSpPr>
-          <p:cNvPr id="12" name="Rectangle 11"/>
-          <p:cNvSpPr/>
-          <p:nvPr/>
-        </p:nvSpPr>
-        <p:spPr>
-          <a:xfrm>
-            <a:off x="8077200" y="2194560"/>
-            <a:ext cx="3627120" cy="2743200"/>
-          </a:xfrm>
-          <a:prstGeom prst="rect">
-            <a:avLst/>
-          </a:prstGeom>
-          <a:solidFill>
-            <a:srgbClr val="ECFDF5"/>
-          </a:solidFill>
-          <a:ln>
-            <a:noFill/>
-          </a:ln>
-        </p:spPr>
-        <p:style>
-          <a:lnRef idx="1">
-            <a:schemeClr val="accent1"/>
-          </a:lnRef>
-          <a:fillRef idx="3">
-            <a:schemeClr val="accent1"/>
-          </a:fillRef>
-          <a:effectRef idx="2">
-            <a:schemeClr val="accent1"/>
-          </a:effectRef>
-          <a:fontRef idx="minor">
-            <a:schemeClr val="lt1"/>
-          </a:fontRef>
-        </p:style>
-        <p:txBody>
-          <a:bodyPr rtlCol="0" anchor="ctr"/>
-          <a:lstStyle/>
-          <a:p>
-            <a:pPr algn="ctr"/>
-          </a:p>
-        </p:txBody>
-      </p:sp>
-      <p:sp>
-        <p:nvSpPr>
-          <p:cNvPr id="13" name="TextBox 12"/>
-          <p:cNvSpPr txBox="1"/>
-          <p:nvPr/>
-        </p:nvSpPr>
-        <p:spPr>
-          <a:xfrm>
-            <a:off x="8168640" y="2286000"/>
-            <a:ext cx="3444240" cy="274320"/>
-          </a:xfrm>
-          <a:prstGeom prst="rect">
-            <a:avLst/>
-          </a:prstGeom>
-          <a:noFill/>
-        </p:spPr>
-        <p:txBody>
-          <a:bodyPr wrap="none">
-            <a:spAutoFit/>
-          </a:bodyPr>
-          <a:lstStyle/>
-          <a:p>
-            <a:r>
-              <a:rPr sz="1500" b="1">
-                <a:solidFill>
-                  <a:srgbClr val="059669"/>
-                </a:solidFill>
-                <a:latin typeface="Calibri"/>
-              </a:rPr>
-              <a:t>Compounding Intelligence</a:t>
-            </a:r>
-          </a:p>
-        </p:txBody>
-      </p:sp>
-      <p:sp>
-        <p:nvSpPr>
-          <p:cNvPr id="14" name="TextBox 13"/>
-          <p:cNvSpPr txBox="1"/>
-          <p:nvPr/>
-        </p:nvSpPr>
-        <p:spPr>
-          <a:xfrm>
-            <a:off x="8168640" y="2514600"/>
-            <a:ext cx="3444240" cy="2377440"/>
-          </a:xfrm>
-          <a:prstGeom prst="rect">
-            <a:avLst/>
-          </a:prstGeom>
-          <a:noFill/>
-        </p:spPr>
-        <p:txBody>
-          <a:bodyPr wrap="square">
-            <a:spAutoFit/>
-          </a:bodyPr>
-          <a:lstStyle/>
-          <a:p>
-            <a:r>
-              <a:rPr sz="1300" b="0">
-                <a:solidFill>
-                  <a:srgbClr val="374151"/>
-                </a:solidFill>
-                <a:latin typeface="Calibri"/>
-              </a:rPr>
-              <a:t>Critic feedback stored in vector memory — quality improves with every build.</a:t>
-            </a:r>
-          </a:p>
-        </p:txBody>
-      </p:sp>
-      <p:sp>
-        <p:nvSpPr>
-          <p:cNvPr id="15" name="TextBox 14"/>
-          <p:cNvSpPr txBox="1"/>
-          <p:nvPr/>
-        </p:nvSpPr>
-        <p:spPr>
-          <a:xfrm>
-            <a:off x="457200" y="5166360"/>
-            <a:ext cx="11247120" cy="274320"/>
-          </a:xfrm>
-          <a:prstGeom prst="rect">
-            <a:avLst/>
-          </a:prstGeom>
-          <a:noFill/>
-        </p:spPr>
-        <p:txBody>
-          <a:bodyPr wrap="square">
-            <a:spAutoFit/>
-          </a:bodyPr>
-          <a:lstStyle/>
-          <a:p>
-            <a:r>
-              <a:rPr sz="1100" b="0">
-                <a:solidFill>
-                  <a:srgbClr val="6B7280"/>
-                </a:solidFill>
-                <a:latin typeface="Calibri"/>
-              </a:rPr>
-              <a:t>One human + SAGE = billion-dollar company infrastructure</a:t>
-            </a:r>
-          </a:p>
-        </p:txBody>
-      </p:sp>
-      <p:sp>
-        <p:nvSpPr>
-          <p:cNvPr id="16" name="Rectangle 15"/>
-          <p:cNvSpPr/>
-          <p:nvPr/>
-        </p:nvSpPr>
-        <p:spPr>
-          <a:xfrm>
-            <a:off x="0" y="6492240"/>
-            <a:ext cx="12188952" cy="365760"/>
-          </a:xfrm>
-          <a:prstGeom prst="rect">
-            <a:avLst/>
-          </a:prstGeom>
-          <a:solidFill>
-            <a:srgbClr val="ECFDF5"/>
-          </a:solidFill>
-          <a:ln>
-            <a:noFill/>
-          </a:ln>
-        </p:spPr>
-        <p:style>
-          <a:lnRef idx="1">
-            <a:schemeClr val="accent1"/>
-          </a:lnRef>
-          <a:fillRef idx="3">
-            <a:schemeClr val="accent1"/>
-          </a:fillRef>
-          <a:effectRef idx="2">
-            <a:schemeClr val="accent1"/>
-          </a:effectRef>
-          <a:fontRef idx="minor">
-            <a:schemeClr val="lt1"/>
-          </a:fontRef>
-        </p:style>
-        <p:txBody>
-          <a:bodyPr rtlCol="0" anchor="ctr"/>
-          <a:lstStyle/>
-          <a:p>
-            <a:pPr algn="ctr"/>
-          </a:p>
-        </p:txBody>
-      </p:sp>
-      <p:sp>
-        <p:nvSpPr>
-          <p:cNvPr id="17" name="TextBox 16"/>
-          <p:cNvSpPr txBox="1"/>
-          <p:nvPr/>
-        </p:nvSpPr>
-        <p:spPr>
-          <a:xfrm>
-            <a:off x="274320" y="6510528"/>
-            <a:ext cx="8229600" cy="274320"/>
-          </a:xfrm>
-          <a:prstGeom prst="rect">
-            <a:avLst/>
-          </a:prstGeom>
-          <a:noFill/>
-        </p:spPr>
-        <p:txBody>
-          <a:bodyPr wrap="none">
-            <a:spAutoFit/>
-          </a:bodyPr>
-          <a:lstStyle/>
-          <a:p>
-            <a:r>
-              <a:rPr sz="900" b="0">
-                <a:solidFill>
-                  <a:srgbClr val="6B7280"/>
-                </a:solidFill>
-                <a:latin typeface="Calibri"/>
-              </a:rPr>
-              <a:t>SAGE[ai] — Open Source (Apache 2.0) | github.com/Sumanharapanahalli/sage | March 2026</a:t>
-            </a:r>
-          </a:p>
-        </p:txBody>
-      </p:sp>
-    </p:spTree>
-  </p:cSld>
-  <p:clrMapOvr>
-    <a:masterClrMapping/>
-  </p:clrMapOvr>
-</p:sld>
-</file>
-
-<file path=ppt/slides/slide15.xml><?xml version="1.0" encoding="utf-8"?>
-<p:sld xmlns:a="http://schemas.openxmlformats.org/drawingml/2006/main" xmlns:p="http://schemas.openxmlformats.org/presentationml/2006/main" xmlns:r="http://schemas.openxmlformats.org/officeDocument/2006/relationships">
-  <p:cSld>
-    <p:spTree>
-      <p:nvGrpSpPr>
-        <p:cNvPr id="1" name=""/>
-        <p:cNvGrpSpPr/>
-        <p:nvPr/>
-      </p:nvGrpSpPr>
-      <p:grpSpPr/>
-      <p:sp>
-        <p:nvSpPr>
-          <p:cNvPr id="2" name="Rectangle 1"/>
-          <p:cNvSpPr/>
-          <p:nvPr/>
-        </p:nvSpPr>
-        <p:spPr>
-          <a:xfrm>
-            <a:off x="0" y="0"/>
-            <a:ext cx="12188952" cy="6858000"/>
-          </a:xfrm>
-          <a:prstGeom prst="rect">
-            <a:avLst/>
-          </a:prstGeom>
-          <a:solidFill>
-            <a:srgbClr val="0D1B2A"/>
-          </a:solidFill>
-          <a:ln>
-            <a:noFill/>
-          </a:ln>
-        </p:spPr>
-        <p:style>
-          <a:lnRef idx="1">
-            <a:schemeClr val="accent1"/>
-          </a:lnRef>
-          <a:fillRef idx="3">
-            <a:schemeClr val="accent1"/>
-          </a:fillRef>
-          <a:effectRef idx="2">
-            <a:schemeClr val="accent1"/>
-          </a:effectRef>
-          <a:fontRef idx="minor">
-            <a:schemeClr val="lt1"/>
-          </a:fontRef>
-        </p:style>
-        <p:txBody>
-          <a:bodyPr rtlCol="0" anchor="ctr"/>
-          <a:lstStyle/>
-          <a:p>
-            <a:pPr algn="ctr"/>
-          </a:p>
-        </p:txBody>
-      </p:sp>
-      <p:sp>
-        <p:nvSpPr>
-          <p:cNvPr id="3" name="Rectangle 2"/>
-          <p:cNvSpPr/>
-          <p:nvPr/>
-        </p:nvSpPr>
-        <p:spPr>
-          <a:xfrm>
-            <a:off x="0" y="3749039"/>
-            <a:ext cx="12188952" cy="54864"/>
-          </a:xfrm>
-          <a:prstGeom prst="rect">
-            <a:avLst/>
-          </a:prstGeom>
-          <a:solidFill>
-            <a:srgbClr val="00B4D8"/>
-          </a:solidFill>
-          <a:ln>
-            <a:noFill/>
-          </a:ln>
-        </p:spPr>
-        <p:style>
-          <a:lnRef idx="1">
-            <a:schemeClr val="accent1"/>
-          </a:lnRef>
-          <a:fillRef idx="3">
-            <a:schemeClr val="accent1"/>
-          </a:fillRef>
-          <a:effectRef idx="2">
-            <a:schemeClr val="accent1"/>
-          </a:effectRef>
-          <a:fontRef idx="minor">
-            <a:schemeClr val="lt1"/>
-          </a:fontRef>
-        </p:style>
-        <p:txBody>
-          <a:bodyPr rtlCol="0" anchor="ctr"/>
-          <a:lstStyle/>
-          <a:p>
-            <a:pPr algn="ctr"/>
-          </a:p>
-        </p:txBody>
-      </p:sp>
-      <p:sp>
-        <p:nvSpPr>
-          <p:cNvPr id="4" name="Rectangle 3"/>
-          <p:cNvSpPr/>
-          <p:nvPr/>
-        </p:nvSpPr>
-        <p:spPr>
-          <a:xfrm>
-            <a:off x="0" y="0"/>
-            <a:ext cx="365760" cy="6858000"/>
-          </a:xfrm>
-          <a:prstGeom prst="rect">
-            <a:avLst/>
-          </a:prstGeom>
-          <a:solidFill>
-            <a:srgbClr val="0078D4"/>
-          </a:solidFill>
-          <a:ln>
-            <a:noFill/>
-          </a:ln>
-        </p:spPr>
-        <p:style>
-          <a:lnRef idx="1">
-            <a:schemeClr val="accent1"/>
-          </a:lnRef>
-          <a:fillRef idx="3">
-            <a:schemeClr val="accent1"/>
-          </a:fillRef>
-          <a:effectRef idx="2">
-            <a:schemeClr val="accent1"/>
-          </a:effectRef>
-          <a:fontRef idx="minor">
-            <a:schemeClr val="lt1"/>
-          </a:fontRef>
-        </p:style>
-        <p:txBody>
-          <a:bodyPr rtlCol="0" anchor="ctr"/>
-          <a:lstStyle/>
-          <a:p>
-            <a:pPr algn="ctr"/>
-          </a:p>
-        </p:txBody>
-      </p:sp>
-      <p:sp>
-        <p:nvSpPr>
           <p:cNvPr id="5" name="TextBox 4"/>
           <p:cNvSpPr txBox="1"/>
           <p:nvPr/>
@@ -7574,7 +6831,7 @@
             <a:r>
               <a:rPr sz="2000" b="0" i="0">
                 <a:solidFill>
-                  <a:srgbClr val="00B4D8"/>
+                  <a:srgbClr val="047857"/>
                 </a:solidFill>
               </a:rPr>
               <a:t>Open source infrastructure for AI-augmented engineering in regulated industries.</a:t>
@@ -7608,10 +6865,10 @@
             <a:r>
               <a:rPr sz="1700" b="0" i="1">
                 <a:solidFill>
-                  <a:srgbClr val="647487"/>
-                </a:solidFill>
-              </a:rPr>
-              <a:t>Apache 2.0. Lean development at machine speed.
+                  <a:srgbClr val="4B5563"/>
+                </a:solidFill>
+              </a:rPr>
+              <a:t>MIT. Lean development at machine speed.
 Compliant by design. Human judgment always in the loop.</a:t>
             </a:r>
           </a:p>
@@ -7745,7 +7002,7 @@
             <a:r>
               <a:rPr sz="1000" b="0" i="1">
                 <a:solidFill>
-                  <a:srgbClr val="647487"/>
+                  <a:srgbClr val="4B5563"/>
                 </a:solidFill>
               </a:rPr>
               <a:t>All financial estimates and projections are assumption-based. Validate with actual data before any investment decision.</a:t>
@@ -7767,7 +7024,7 @@
     <p:bg>
       <p:bgPr>
         <a:solidFill>
-          <a:srgbClr val="F0F4F8"/>
+          <a:srgbClr val="FAFAFA"/>
         </a:solidFill>
         <a:effectLst/>
       </p:bgPr>
@@ -7794,7 +7051,7 @@
             <a:avLst/>
           </a:prstGeom>
           <a:solidFill>
-            <a:srgbClr val="0D1B2A"/>
+            <a:srgbClr val="1F2A37"/>
           </a:solidFill>
           <a:ln>
             <a:noFill/>
@@ -7882,7 +7139,7 @@
             <a:r>
               <a:rPr sz="1600" b="0" i="0">
                 <a:solidFill>
-                  <a:srgbClr val="00B4D8"/>
+                  <a:srgbClr val="047857"/>
                 </a:solidFill>
               </a:rPr>
               <a:t>The opportunity and our position — in brief</a:t>
@@ -7916,7 +7173,7 @@
             <a:r>
               <a:rPr sz="1600" b="1" i="0">
                 <a:solidFill>
-                  <a:srgbClr val="0078D4"/>
+                  <a:srgbClr val="10B981"/>
                 </a:solidFill>
               </a:rPr>
               <a:t>The Opportunity</a:t>
@@ -7950,7 +7207,7 @@
             <a:r>
               <a:rPr sz="1300" b="0" i="0">
                 <a:solidFill>
-                  <a:srgbClr val="0D1B2A"/>
+                  <a:srgbClr val="1F2A37"/>
                 </a:solidFill>
               </a:rPr>
               <a:t>AI in manufacturing software: $3.8B (2023) to $68.4B (2032), 38% CAGR</a:t>
@@ -7984,7 +7241,7 @@
             <a:r>
               <a:rPr sz="1300" b="0" i="0">
                 <a:solidFill>
-                  <a:srgbClr val="0D1B2A"/>
+                  <a:srgbClr val="1F2A37"/>
                 </a:solidFill>
               </a:rPr>
               <a:t>Regulated industries (medical devices, aerospace, pharma) are under-served</a:t>
@@ -8018,7 +7275,7 @@
             <a:r>
               <a:rPr sz="1300" b="0" i="0">
                 <a:solidFill>
-                  <a:srgbClr val="0D1B2A"/>
+                  <a:srgbClr val="1F2A37"/>
                 </a:solidFill>
               </a:rPr>
               <a:t>Compliance requirements create 60+ hours per week of preventable manual work</a:t>
@@ -8052,7 +7309,7 @@
             <a:r>
               <a:rPr sz="1600" b="1" i="0">
                 <a:solidFill>
-                  <a:srgbClr val="21C55D"/>
+                  <a:srgbClr val="10B981"/>
                 </a:solidFill>
               </a:rPr>
               <a:t>Our Position</a:t>
@@ -8086,7 +7343,7 @@
             <a:r>
               <a:rPr sz="1300" b="0" i="0">
                 <a:solidFill>
-                  <a:srgbClr val="0D1B2A"/>
+                  <a:srgbClr val="1F2A37"/>
                 </a:solidFill>
               </a:rPr>
               <a:t>Production-ready AI agent framework — human-in-the-loop compliance by design</a:t>
@@ -8120,7 +7377,7 @@
             <a:r>
               <a:rPr sz="1300" b="0" i="0">
                 <a:solidFill>
-                  <a:srgbClr val="0D1B2A"/>
+                  <a:srgbClr val="1F2A37"/>
                 </a:solidFill>
               </a:rPr>
               <a:t>12 integration phases complete — live in regulated production environments</a:t>
@@ -8154,7 +7411,7 @@
             <a:r>
               <a:rPr sz="1300" b="0" i="0">
                 <a:solidFill>
-                  <a:srgbClr val="0D1B2A"/>
+                  <a:srgbClr val="1F2A37"/>
                 </a:solidFill>
               </a:rPr>
               <a:t>Seeking Series A to accelerate sales, expand integrations, and grow the team</a:t>
@@ -8177,7 +7434,7 @@
             <a:avLst/>
           </a:prstGeom>
           <a:solidFill>
-            <a:srgbClr val="00B4D8"/>
+            <a:srgbClr val="047857"/>
           </a:solidFill>
           <a:ln>
             <a:noFill/>
@@ -8220,7 +7477,7 @@
             <a:avLst/>
           </a:prstGeom>
           <a:solidFill>
-            <a:srgbClr val="0D1B2A"/>
+            <a:srgbClr val="1F2A37"/>
           </a:solidFill>
           <a:ln>
             <a:noFill/>
@@ -8274,10 +7531,10 @@
             <a:r>
               <a:rPr sz="900" b="0" i="0">
                 <a:solidFill>
-                  <a:srgbClr val="647487"/>
-                </a:solidFill>
-              </a:rPr>
-              <a:t>SAGE[ai] — Open Source (Apache 2.0) | github.com/Sumanharapanahalli/sage | March 2026</a:t>
+                  <a:srgbClr val="4B5563"/>
+                </a:solidFill>
+              </a:rPr>
+              <a:t>SAGE[ai] — Open Source (MIT) | github.com/Sumanharapanahalli/sage | March 2026</a:t>
             </a:r>
           </a:p>
         </p:txBody>
@@ -8296,7 +7553,7 @@
     <p:bg>
       <p:bgPr>
         <a:solidFill>
-          <a:srgbClr val="F0F4F8"/>
+          <a:srgbClr val="FAFAFA"/>
         </a:solidFill>
         <a:effectLst/>
       </p:bgPr>
@@ -8323,7 +7580,7 @@
             <a:avLst/>
           </a:prstGeom>
           <a:solidFill>
-            <a:srgbClr val="0D1B2A"/>
+            <a:srgbClr val="1F2A37"/>
           </a:solidFill>
           <a:ln>
             <a:noFill/>
@@ -8411,7 +7668,7 @@
             <a:r>
               <a:rPr sz="1600" b="0" i="0">
                 <a:solidFill>
-                  <a:srgbClr val="00B4D8"/>
+                  <a:srgbClr val="047857"/>
                 </a:solidFill>
               </a:rPr>
               <a:t>60+ hours per week of preventable waste in every regulated engineering team</a:t>
@@ -8461,7 +7718,7 @@
                   </a:txBody>
                   <a:tcPr>
                     <a:solidFill>
-                      <a:srgbClr val="0078D4"/>
+                      <a:srgbClr val="10B981"/>
                     </a:solidFill>
                   </a:tcPr>
                 </a:tc>
@@ -8483,7 +7740,7 @@
                   </a:txBody>
                   <a:tcPr>
                     <a:solidFill>
-                      <a:srgbClr val="0078D4"/>
+                      <a:srgbClr val="10B981"/>
                     </a:solidFill>
                   </a:tcPr>
                 </a:tc>
@@ -8505,7 +7762,7 @@
                   </a:txBody>
                   <a:tcPr>
                     <a:solidFill>
-                      <a:srgbClr val="0078D4"/>
+                      <a:srgbClr val="10B981"/>
                     </a:solidFill>
                   </a:tcPr>
                 </a:tc>
@@ -8520,7 +7777,7 @@
                       <a:r>
                         <a:rPr sz="1200">
                           <a:solidFill>
-                            <a:srgbClr val="0D1B2A"/>
+                            <a:srgbClr val="1F2A37"/>
                           </a:solidFill>
                         </a:rPr>
                         <a:t>Error log analysis</a:t>
@@ -8529,7 +7786,7 @@
                   </a:txBody>
                   <a:tcPr>
                     <a:solidFill>
-                      <a:srgbClr val="F0F4F8"/>
+                      <a:srgbClr val="FAFAFA"/>
                     </a:solidFill>
                   </a:tcPr>
                 </a:tc>
@@ -8542,7 +7799,7 @@
                       <a:r>
                         <a:rPr sz="1200">
                           <a:solidFill>
-                            <a:srgbClr val="0D1B2A"/>
+                            <a:srgbClr val="1F2A37"/>
                           </a:solidFill>
                         </a:rPr>
                         <a:t>45 min per event, 10 events/day, 2 engineers</a:t>
@@ -8551,7 +7808,7 @@
                   </a:txBody>
                   <a:tcPr>
                     <a:solidFill>
-                      <a:srgbClr val="F0F4F8"/>
+                      <a:srgbClr val="FAFAFA"/>
                     </a:solidFill>
                   </a:tcPr>
                 </a:tc>
@@ -8564,7 +7821,7 @@
                       <a:r>
                         <a:rPr sz="1200">
                           <a:solidFill>
-                            <a:srgbClr val="0D1B2A"/>
+                            <a:srgbClr val="1F2A37"/>
                           </a:solidFill>
                         </a:rPr>
                         <a:t>~780 engineer-hours per year</a:t>
@@ -8573,7 +7830,7 @@
                   </a:txBody>
                   <a:tcPr>
                     <a:solidFill>
-                      <a:srgbClr val="F0F4F8"/>
+                      <a:srgbClr val="FAFAFA"/>
                     </a:solidFill>
                   </a:tcPr>
                 </a:tc>
@@ -8588,7 +7845,7 @@
                       <a:r>
                         <a:rPr sz="1200">
                           <a:solidFill>
-                            <a:srgbClr val="0D1B2A"/>
+                            <a:srgbClr val="1F2A37"/>
                           </a:solidFill>
                         </a:rPr>
                         <a:t>Code review backlog</a:t>
@@ -8610,7 +7867,7 @@
                       <a:r>
                         <a:rPr sz="1200">
                           <a:solidFill>
-                            <a:srgbClr val="0D1B2A"/>
+                            <a:srgbClr val="1F2A37"/>
                           </a:solidFill>
                         </a:rPr>
                         <a:t>3 hours per MR, 15 MRs per week</a:t>
@@ -8632,7 +7889,7 @@
                       <a:r>
                         <a:rPr sz="1200">
                           <a:solidFill>
-                            <a:srgbClr val="0D1B2A"/>
+                            <a:srgbClr val="1F2A37"/>
                           </a:solidFill>
                         </a:rPr>
                         <a:t>~2,340 engineer-hours per year</a:t>
@@ -8656,7 +7913,7 @@
                       <a:r>
                         <a:rPr sz="1200">
                           <a:solidFill>
-                            <a:srgbClr val="0D1B2A"/>
+                            <a:srgbClr val="1F2A37"/>
                           </a:solidFill>
                         </a:rPr>
                         <a:t>Compliance reporting</a:t>
@@ -8665,7 +7922,7 @@
                   </a:txBody>
                   <a:tcPr>
                     <a:solidFill>
-                      <a:srgbClr val="F0F4F8"/>
+                      <a:srgbClr val="FAFAFA"/>
                     </a:solidFill>
                   </a:tcPr>
                 </a:tc>
@@ -8678,7 +7935,7 @@
                       <a:r>
                         <a:rPr sz="1200">
                           <a:solidFill>
-                            <a:srgbClr val="0D1B2A"/>
+                            <a:srgbClr val="1F2A37"/>
                           </a:solidFill>
                         </a:rPr>
                         <a:t>8+ hours per week, manual, error-prone</a:t>
@@ -8687,7 +7944,7 @@
                   </a:txBody>
                   <a:tcPr>
                     <a:solidFill>
-                      <a:srgbClr val="F0F4F8"/>
+                      <a:srgbClr val="FAFAFA"/>
                     </a:solidFill>
                   </a:tcPr>
                 </a:tc>
@@ -8700,7 +7957,7 @@
                       <a:r>
                         <a:rPr sz="1200">
                           <a:solidFill>
-                            <a:srgbClr val="0D1B2A"/>
+                            <a:srgbClr val="1F2A37"/>
                           </a:solidFill>
                         </a:rPr>
                         <a:t>~416 engineer-hours per year</a:t>
@@ -8709,7 +7966,7 @@
                   </a:txBody>
                   <a:tcPr>
                     <a:solidFill>
-                      <a:srgbClr val="F0F4F8"/>
+                      <a:srgbClr val="FAFAFA"/>
                     </a:solidFill>
                   </a:tcPr>
                 </a:tc>
@@ -8724,7 +7981,7 @@
                       <a:r>
                         <a:rPr sz="1200">
                           <a:solidFill>
-                            <a:srgbClr val="0D1B2A"/>
+                            <a:srgbClr val="1F2A37"/>
                           </a:solidFill>
                         </a:rPr>
                         <a:t>Knowledge attrition</a:t>
@@ -8746,7 +8003,7 @@
                       <a:r>
                         <a:rPr sz="1200">
                           <a:solidFill>
-                            <a:srgbClr val="0D1B2A"/>
+                            <a:srgbClr val="1F2A37"/>
                           </a:solidFill>
                         </a:rPr>
                         <a:t>Expert context lost permanently on departure</a:t>
@@ -8768,7 +8025,7 @@
                       <a:r>
                         <a:rPr sz="1200">
                           <a:solidFill>
-                            <a:srgbClr val="0D1B2A"/>
+                            <a:srgbClr val="1F2A37"/>
                           </a:solidFill>
                         </a:rPr>
                         <a:t>Unquantifiable, recurring</a:t>
@@ -8792,7 +8049,7 @@
                       <a:r>
                         <a:rPr sz="1200">
                           <a:solidFill>
-                            <a:srgbClr val="0D1B2A"/>
+                            <a:srgbClr val="1F2A37"/>
                           </a:solidFill>
                         </a:rPr>
                         <a:t>TOTAL IMPACT</a:t>
@@ -8801,7 +8058,7 @@
                   </a:txBody>
                   <a:tcPr>
                     <a:solidFill>
-                      <a:srgbClr val="F0F4F8"/>
+                      <a:srgbClr val="FAFAFA"/>
                     </a:solidFill>
                   </a:tcPr>
                 </a:tc>
@@ -8814,7 +8071,7 @@
                       <a:r>
                         <a:rPr sz="1200">
                           <a:solidFill>
-                            <a:srgbClr val="0D1B2A"/>
+                            <a:srgbClr val="1F2A37"/>
                           </a:solidFill>
                         </a:rPr>
                         <a:t>~68 hrs/week per team of 10 engineers</a:t>
@@ -8823,7 +8080,7 @@
                   </a:txBody>
                   <a:tcPr>
                     <a:solidFill>
-                      <a:srgbClr val="F0F4F8"/>
+                      <a:srgbClr val="FAFAFA"/>
                     </a:solidFill>
                   </a:tcPr>
                 </a:tc>
@@ -8836,7 +8093,7 @@
                       <a:r>
                         <a:rPr sz="1200">
                           <a:solidFill>
-                            <a:srgbClr val="0D1B2A"/>
+                            <a:srgbClr val="1F2A37"/>
                           </a:solidFill>
                         </a:rPr>
                         <a:t>~1.7 FTE equivalent per year*</a:t>
@@ -8845,7 +8102,7 @@
                   </a:txBody>
                   <a:tcPr>
                     <a:solidFill>
-                      <a:srgbClr val="F0F4F8"/>
+                      <a:srgbClr val="FAFAFA"/>
                     </a:solidFill>
                   </a:tcPr>
                 </a:tc>
@@ -8880,7 +8137,7 @@
             <a:r>
               <a:rPr sz="1100" b="0" i="1">
                 <a:solidFill>
-                  <a:srgbClr val="647487"/>
+                  <a:srgbClr val="4B5563"/>
                 </a:solidFill>
               </a:rPr>
               <a:t>* All figures are assumption-based estimates derived from industry benchmarks. Validate with actual team data.</a:t>
@@ -8903,7 +8160,7 @@
             <a:avLst/>
           </a:prstGeom>
           <a:solidFill>
-            <a:srgbClr val="0D1B2A"/>
+            <a:srgbClr val="1F2A37"/>
           </a:solidFill>
           <a:ln>
             <a:noFill/>
@@ -8957,10 +8214,10 @@
             <a:r>
               <a:rPr sz="900" b="0" i="0">
                 <a:solidFill>
-                  <a:srgbClr val="647487"/>
-                </a:solidFill>
-              </a:rPr>
-              <a:t>SAGE[ai] — Open Source (Apache 2.0) | github.com/Sumanharapanahalli/sage | March 2026</a:t>
+                  <a:srgbClr val="4B5563"/>
+                </a:solidFill>
+              </a:rPr>
+              <a:t>SAGE[ai] — Open Source (MIT) | github.com/Sumanharapanahalli/sage | March 2026</a:t>
             </a:r>
           </a:p>
         </p:txBody>
@@ -9056,7 +8313,7 @@
     <p:bg>
       <p:bgPr>
         <a:solidFill>
-          <a:srgbClr val="F0F4F8"/>
+          <a:srgbClr val="FAFAFA"/>
         </a:solidFill>
         <a:effectLst/>
       </p:bgPr>
@@ -9083,7 +8340,7 @@
             <a:avLst/>
           </a:prstGeom>
           <a:solidFill>
-            <a:srgbClr val="0D1B2A"/>
+            <a:srgbClr val="1F2A37"/>
           </a:solidFill>
           <a:ln>
             <a:noFill/>
@@ -9171,7 +8428,7 @@
             <a:r>
               <a:rPr sz="1600" b="0" i="0">
                 <a:solidFill>
-                  <a:srgbClr val="00B4D8"/>
+                  <a:srgbClr val="047857"/>
                 </a:solidFill>
               </a:rPr>
               <a:t>Agents surface signals, propose actions, wait for human approval, and learn from every correction</a:t>
@@ -9205,7 +8462,7 @@
             <a:r>
               <a:rPr sz="1500" b="0" i="0">
                 <a:solidFill>
-                  <a:srgbClr val="0D1B2A"/>
+                  <a:srgbClr val="1F2A37"/>
                 </a:solidFill>
               </a:rPr>
               <a:t>Analyzes error logs in under 60 seconds — versus 45-60 minutes manual</a:t>
@@ -9239,7 +8496,7 @@
             <a:r>
               <a:rPr sz="1500" b="0" i="0">
                 <a:solidFill>
-                  <a:srgbClr val="0D1B2A"/>
+                  <a:srgbClr val="1F2A37"/>
                 </a:solidFill>
               </a:rPr>
               <a:t>AI-assisted code review with multi-step reasoning and pipeline status</a:t>
@@ -9273,7 +8530,7 @@
             <a:r>
               <a:rPr sz="1500" b="0" i="0">
                 <a:solidFill>
-                  <a:srgbClr val="0D1B2A"/>
+                  <a:srgbClr val="1F2A37"/>
                 </a:solidFill>
               </a:rPr>
               <a:t>Monitors Microsoft Teams, Metabase, and GitLab in real time</a:t>
@@ -9307,7 +8564,7 @@
             <a:r>
               <a:rPr sz="1500" b="0" i="0">
                 <a:solidFill>
-                  <a:srgbClr val="0D1B2A"/>
+                  <a:srgbClr val="1F2A37"/>
                 </a:solidFill>
               </a:rPr>
               <a:t>Human approval gate on every proposal — enforced in code, never bypassed</a:t>
@@ -9341,7 +8598,7 @@
             <a:r>
               <a:rPr sz="1500" b="0" i="0">
                 <a:solidFill>
-                  <a:srgbClr val="0D1B2A"/>
+                  <a:srgbClr val="1F2A37"/>
                 </a:solidFill>
               </a:rPr>
               <a:t>Every decision logged to an immutable, ISO 13485-compliant audit trail</a:t>
@@ -9375,7 +8632,7 @@
             <a:r>
               <a:rPr sz="1500" b="0" i="0">
                 <a:solidFill>
-                  <a:srgbClr val="0D1B2A"/>
+                  <a:srgbClr val="1F2A37"/>
                 </a:solidFill>
               </a:rPr>
               <a:t>Learns from every correction via vector memory — improves without model retraining</a:t>
@@ -9409,7 +8666,7 @@
             <a:r>
               <a:rPr sz="1500" b="0" i="0">
                 <a:solidFill>
-                  <a:srgbClr val="0D1B2A"/>
+                  <a:srgbClr val="1F2A37"/>
                 </a:solidFill>
               </a:rPr>
               <a:t>YAML-first architecture: new industry domain configured in under 60 seconds</a:t>
@@ -9432,7 +8689,7 @@
             <a:avLst/>
           </a:prstGeom>
           <a:solidFill>
-            <a:srgbClr val="0D1B2A"/>
+            <a:srgbClr val="1F2A37"/>
           </a:solidFill>
           <a:ln>
             <a:noFill/>
@@ -9486,10 +8743,10 @@
             <a:r>
               <a:rPr sz="900" b="0" i="0">
                 <a:solidFill>
-                  <a:srgbClr val="647487"/>
-                </a:solidFill>
-              </a:rPr>
-              <a:t>SAGE[ai] — Open Source (Apache 2.0) | github.com/Sumanharapanahalli/sage | March 2026</a:t>
+                  <a:srgbClr val="4B5563"/>
+                </a:solidFill>
+              </a:rPr>
+              <a:t>SAGE[ai] — Open Source (MIT) | github.com/Sumanharapanahalli/sage | March 2026</a:t>
             </a:r>
           </a:p>
         </p:txBody>
@@ -9508,7 +8765,7 @@
     <p:bg>
       <p:bgPr>
         <a:solidFill>
-          <a:srgbClr val="F0F4F8"/>
+          <a:srgbClr val="FAFAFA"/>
         </a:solidFill>
         <a:effectLst/>
       </p:bgPr>
@@ -9535,7 +8792,7 @@
             <a:avLst/>
           </a:prstGeom>
           <a:solidFill>
-            <a:srgbClr val="0D1B2A"/>
+            <a:srgbClr val="1F2A37"/>
           </a:solidFill>
           <a:ln>
             <a:noFill/>
@@ -9623,7 +8880,7 @@
             <a:r>
               <a:rPr sz="1600" b="0" i="0">
                 <a:solidFill>
-                  <a:srgbClr val="00B4D8"/>
+                  <a:srgbClr val="047857"/>
                 </a:solidFill>
               </a:rPr>
               <a:t>Regulated industry engineering software is a clear white space for agentic AI</a:t>
@@ -9646,7 +8903,7 @@
             <a:avLst/>
           </a:prstGeom>
           <a:solidFill>
-            <a:srgbClr val="0D1B2A"/>
+            <a:srgbClr val="1F2A37"/>
           </a:solidFill>
           <a:ln>
             <a:noFill/>
@@ -9768,7 +9025,7 @@
             <a:r>
               <a:rPr sz="1100" b="0" i="1">
                 <a:solidFill>
-                  <a:srgbClr val="F0F4F8"/>
+                  <a:srgbClr val="FAFAFA"/>
                 </a:solidFill>
               </a:rPr>
               <a:t>38% CAGR from $3.8B in 2023</a:t>
@@ -9791,7 +9048,7 @@
             <a:avLst/>
           </a:prstGeom>
           <a:solidFill>
-            <a:srgbClr val="0078D4"/>
+            <a:srgbClr val="10B981"/>
           </a:solidFill>
           <a:ln>
             <a:noFill/>
@@ -9913,7 +9170,7 @@
             <a:r>
               <a:rPr sz="1100" b="0" i="1">
                 <a:solidFill>
-                  <a:srgbClr val="F0F4F8"/>
+                  <a:srgbClr val="FAFAFA"/>
                 </a:solidFill>
               </a:rPr>
               <a:t>Medical devices, pharma, aerospace</a:t>
@@ -9936,7 +9193,7 @@
             <a:avLst/>
           </a:prstGeom>
           <a:solidFill>
-            <a:srgbClr val="00B4D8"/>
+            <a:srgbClr val="047857"/>
           </a:solidFill>
           <a:ln>
             <a:noFill/>
@@ -10058,7 +9315,7 @@
             <a:r>
               <a:rPr sz="1100" b="0" i="1">
                 <a:solidFill>
-                  <a:srgbClr val="F0F4F8"/>
+                  <a:srgbClr val="FAFAFA"/>
                 </a:solidFill>
               </a:rPr>
               <a:t>Growing at 12% CAGR</a:t>
@@ -10092,7 +9349,7 @@
             <a:r>
               <a:rPr sz="1100" b="0" i="1">
                 <a:solidFill>
-                  <a:srgbClr val="647487"/>
+                  <a:srgbClr val="4B5563"/>
                 </a:solidFill>
               </a:rPr>
               <a:t>Sources: MarketsandMarkets, Grand View Research, Gartner — 2024 industry reports.</a:t>
@@ -10115,7 +9372,7 @@
             <a:avLst/>
           </a:prstGeom>
           <a:solidFill>
-            <a:srgbClr val="0D1B2A"/>
+            <a:srgbClr val="1F2A37"/>
           </a:solidFill>
           <a:ln>
             <a:noFill/>
@@ -10169,10 +9426,10 @@
             <a:r>
               <a:rPr sz="900" b="0" i="0">
                 <a:solidFill>
-                  <a:srgbClr val="647487"/>
-                </a:solidFill>
-              </a:rPr>
-              <a:t>SAGE[ai] — Open Source (Apache 2.0) | github.com/Sumanharapanahalli/sage | March 2026</a:t>
+                  <a:srgbClr val="4B5563"/>
+                </a:solidFill>
+              </a:rPr>
+              <a:t>SAGE[ai] — Open Source (MIT) | github.com/Sumanharapanahalli/sage | March 2026</a:t>
             </a:r>
           </a:p>
         </p:txBody>
@@ -10191,7 +9448,7 @@
     <p:bg>
       <p:bgPr>
         <a:solidFill>
-          <a:srgbClr val="F0F4F8"/>
+          <a:srgbClr val="FAFAFA"/>
         </a:solidFill>
         <a:effectLst/>
       </p:bgPr>
@@ -10218,7 +9475,7 @@
             <a:avLst/>
           </a:prstGeom>
           <a:solidFill>
-            <a:srgbClr val="0D1B2A"/>
+            <a:srgbClr val="1F2A37"/>
           </a:solidFill>
           <a:ln>
             <a:noFill/>
@@ -10275,7 +9532,7 @@
                   <a:srgbClr val="FFFFFF"/>
                 </a:solidFill>
               </a:rPr>
-              <a:t>Platform Capabilities — 136 Endpoints, Open Source (Apache 2.0)</a:t>
+              <a:t>Platform Capabilities — 136 Endpoints, Open Source (MIT)</a:t>
             </a:r>
           </a:p>
         </p:txBody>
@@ -10306,7 +9563,7 @@
             <a:r>
               <a:rPr sz="1600" b="0" i="0">
                 <a:solidFill>
-                  <a:srgbClr val="00B4D8"/>
+                  <a:srgbClr val="047857"/>
                 </a:solidFill>
               </a:rPr>
               <a:t>From core agent loop to enterprise-grade orchestration — all production-ready, all open source</a:t>
@@ -10356,7 +9613,7 @@
                   </a:txBody>
                   <a:tcPr>
                     <a:solidFill>
-                      <a:srgbClr val="0078D4"/>
+                      <a:srgbClr val="10B981"/>
                     </a:solidFill>
                   </a:tcPr>
                 </a:tc>
@@ -10378,7 +9635,7 @@
                   </a:txBody>
                   <a:tcPr>
                     <a:solidFill>
-                      <a:srgbClr val="0078D4"/>
+                      <a:srgbClr val="10B981"/>
                     </a:solidFill>
                   </a:tcPr>
                 </a:tc>
@@ -10400,7 +9657,7 @@
                   </a:txBody>
                   <a:tcPr>
                     <a:solidFill>
-                      <a:srgbClr val="0078D4"/>
+                      <a:srgbClr val="10B981"/>
                     </a:solidFill>
                   </a:tcPr>
                 </a:tc>
@@ -10415,7 +9672,7 @@
                       <a:r>
                         <a:rPr sz="1200">
                           <a:solidFill>
-                            <a:srgbClr val="0D1B2A"/>
+                            <a:srgbClr val="1F2A37"/>
                           </a:solidFill>
                         </a:rPr>
                         <a:t>Intelligent Analysis</a:t>
@@ -10424,7 +9681,7 @@
                   </a:txBody>
                   <a:tcPr>
                     <a:solidFill>
-                      <a:srgbClr val="F0F4F8"/>
+                      <a:srgbClr val="FAFAFA"/>
                     </a:solidFill>
                   </a:tcPr>
                 </a:tc>
@@ -10437,7 +9694,7 @@
                       <a:r>
                         <a:rPr sz="1200">
                           <a:solidFill>
-                            <a:srgbClr val="0D1B2A"/>
+                            <a:srgbClr val="1F2A37"/>
                           </a:solidFill>
                         </a:rPr>
                         <a:t>AI triage of error logs, severity scoring, root-cause reasoning</a:t>
@@ -10446,7 +9703,7 @@
                   </a:txBody>
                   <a:tcPr>
                     <a:solidFill>
-                      <a:srgbClr val="F0F4F8"/>
+                      <a:srgbClr val="FAFAFA"/>
                     </a:solidFill>
                   </a:tcPr>
                 </a:tc>
@@ -10459,7 +9716,7 @@
                       <a:r>
                         <a:rPr sz="1200">
                           <a:solidFill>
-                            <a:srgbClr val="0D1B2A"/>
+                            <a:srgbClr val="1F2A37"/>
                           </a:solidFill>
                         </a:rPr>
                         <a:t>45 min reduced to under 60 seconds</a:t>
@@ -10468,7 +9725,7 @@
                   </a:txBody>
                   <a:tcPr>
                     <a:solidFill>
-                      <a:srgbClr val="F0F4F8"/>
+                      <a:srgbClr val="FAFAFA"/>
                     </a:solidFill>
                   </a:tcPr>
                 </a:tc>
@@ -10483,7 +9740,7 @@
                       <a:r>
                         <a:rPr sz="1200">
                           <a:solidFill>
-                            <a:srgbClr val="0D1B2A"/>
+                            <a:srgbClr val="1F2A37"/>
                           </a:solidFill>
                         </a:rPr>
                         <a:t>Automated Code Review</a:t>
@@ -10505,7 +9762,7 @@
                       <a:r>
                         <a:rPr sz="1200">
                           <a:solidFill>
-                            <a:srgbClr val="0D1B2A"/>
+                            <a:srgbClr val="1F2A37"/>
                           </a:solidFill>
                         </a:rPr>
                         <a:t>Multi-step ReAct reasoning loop on merge requests</a:t>
@@ -10527,7 +9784,7 @@
                       <a:r>
                         <a:rPr sz="1200">
                           <a:solidFill>
-                            <a:srgbClr val="0D1B2A"/>
+                            <a:srgbClr val="1F2A37"/>
                           </a:solidFill>
                         </a:rPr>
                         <a:t>3-hour review reduced to minutes</a:t>
@@ -10551,7 +9808,7 @@
                       <a:r>
                         <a:rPr sz="1200">
                           <a:solidFill>
-                            <a:srgbClr val="0D1B2A"/>
+                            <a:srgbClr val="1F2A37"/>
                           </a:solidFill>
                         </a:rPr>
                         <a:t>Durable Workflows</a:t>
@@ -10560,7 +9817,7 @@
                   </a:txBody>
                   <a:tcPr>
                     <a:solidFill>
-                      <a:srgbClr val="F0F4F8"/>
+                      <a:srgbClr val="FAFAFA"/>
                     </a:solidFill>
                   </a:tcPr>
                 </a:tc>
@@ -10573,7 +9830,7 @@
                       <a:r>
                         <a:rPr sz="1200">
                           <a:solidFill>
-                            <a:srgbClr val="0D1B2A"/>
+                            <a:srgbClr val="1F2A37"/>
                           </a:solidFill>
                         </a:rPr>
                         <a:t>LangGraph interrupt/resume and Temporal — survives server restart</a:t>
@@ -10582,7 +9839,7 @@
                   </a:txBody>
                   <a:tcPr>
                     <a:solidFill>
-                      <a:srgbClr val="F0F4F8"/>
+                      <a:srgbClr val="FAFAFA"/>
                     </a:solidFill>
                   </a:tcPr>
                 </a:tc>
@@ -10595,7 +9852,7 @@
                       <a:r>
                         <a:rPr sz="1200">
                           <a:solidFill>
-                            <a:srgbClr val="0D1B2A"/>
+                            <a:srgbClr val="1F2A37"/>
                           </a:solidFill>
                         </a:rPr>
                         <a:t>Zero lost work in long processes</a:t>
@@ -10604,7 +9861,7 @@
                   </a:txBody>
                   <a:tcPr>
                     <a:solidFill>
-                      <a:srgbClr val="F0F4F8"/>
+                      <a:srgbClr val="FAFAFA"/>
                     </a:solidFill>
                   </a:tcPr>
                 </a:tc>
@@ -10619,7 +9876,7 @@
                       <a:r>
                         <a:rPr sz="1200">
                           <a:solidFill>
-                            <a:srgbClr val="0D1B2A"/>
+                            <a:srgbClr val="1F2A37"/>
                           </a:solidFill>
                         </a:rPr>
                         <a:t>Onboarding Wizard</a:t>
@@ -10641,7 +9898,7 @@
                       <a:r>
                         <a:rPr sz="1200">
                           <a:solidFill>
-                            <a:srgbClr val="0D1B2A"/>
+                            <a:srgbClr val="1F2A37"/>
                           </a:solidFill>
                         </a:rPr>
                         <a:t>Plain-language description generates full domain config in 60 seconds</a:t>
@@ -10663,7 +9920,7 @@
                       <a:r>
                         <a:rPr sz="1200">
                           <a:solidFill>
-                            <a:srgbClr val="0D1B2A"/>
+                            <a:srgbClr val="1F2A37"/>
                           </a:solidFill>
                         </a:rPr>
                         <a:t>New vertical in under 1 hour</a:t>
@@ -10687,7 +9944,7 @@
                       <a:r>
                         <a:rPr sz="1200">
                           <a:solidFill>
-                            <a:srgbClr val="0D1B2A"/>
+                            <a:srgbClr val="1F2A37"/>
                           </a:solidFill>
                         </a:rPr>
                         <a:t>Evaluation Framework</a:t>
@@ -10696,7 +9953,7 @@
                   </a:txBody>
                   <a:tcPr>
                     <a:solidFill>
-                      <a:srgbClr val="F0F4F8"/>
+                      <a:srgbClr val="FAFAFA"/>
                     </a:solidFill>
                   </a:tcPr>
                 </a:tc>
@@ -10709,7 +9966,7 @@
                       <a:r>
                         <a:rPr sz="1200">
                           <a:solidFill>
-                            <a:srgbClr val="0D1B2A"/>
+                            <a:srgbClr val="1F2A37"/>
                           </a:solidFill>
                         </a:rPr>
                         <a:t>YAML test suites with 0-100 scoring and regression tracking</a:t>
@@ -10718,7 +9975,7 @@
                   </a:txBody>
                   <a:tcPr>
                     <a:solidFill>
-                      <a:srgbClr val="F0F4F8"/>
+                      <a:srgbClr val="FAFAFA"/>
                     </a:solidFill>
                   </a:tcPr>
                 </a:tc>
@@ -10731,7 +9988,7 @@
                       <a:r>
                         <a:rPr sz="1200">
                           <a:solidFill>
-                            <a:srgbClr val="0D1B2A"/>
+                            <a:srgbClr val="1F2A37"/>
                           </a:solidFill>
                         </a:rPr>
                         <a:t>Measurable agent quality over time</a:t>
@@ -10740,7 +9997,7 @@
                   </a:txBody>
                   <a:tcPr>
                     <a:solidFill>
-                      <a:srgbClr val="F0F4F8"/>
+                      <a:srgbClr val="FAFAFA"/>
                     </a:solidFill>
                   </a:tcPr>
                 </a:tc>
@@ -10755,7 +10012,7 @@
                       <a:r>
                         <a:rPr sz="1200">
                           <a:solidFill>
-                            <a:srgbClr val="0D1B2A"/>
+                            <a:srgbClr val="1F2A37"/>
                           </a:solidFill>
                         </a:rPr>
                         <a:t>Multi-Tenant Isolation</a:t>
@@ -10777,7 +10034,7 @@
                       <a:r>
                         <a:rPr sz="1200">
                           <a:solidFill>
-                            <a:srgbClr val="0D1B2A"/>
+                            <a:srgbClr val="1F2A37"/>
                           </a:solidFill>
                         </a:rPr>
                         <a:t>Per-team knowledge namespacing via request header</a:t>
@@ -10799,7 +10056,7 @@
                       <a:r>
                         <a:rPr sz="1200">
                           <a:solidFill>
-                            <a:srgbClr val="0D1B2A"/>
+                            <a:srgbClr val="1F2A37"/>
                           </a:solidFill>
                         </a:rPr>
                         <a:t>Enterprise-ready, single deployment</a:t>
@@ -10823,7 +10080,7 @@
                       <a:r>
                         <a:rPr sz="1200">
                           <a:solidFill>
-                            <a:srgbClr val="0D1B2A"/>
+                            <a:srgbClr val="1F2A37"/>
                           </a:solidFill>
                         </a:rPr>
                         <a:t>Slack Approvals</a:t>
@@ -10832,7 +10089,7 @@
                   </a:txBody>
                   <a:tcPr>
                     <a:solidFill>
-                      <a:srgbClr val="F0F4F8"/>
+                      <a:srgbClr val="FAFAFA"/>
                     </a:solidFill>
                   </a:tcPr>
                 </a:tc>
@@ -10845,7 +10102,7 @@
                       <a:r>
                         <a:rPr sz="1200">
                           <a:solidFill>
-                            <a:srgbClr val="0D1B2A"/>
+                            <a:srgbClr val="1F2A37"/>
                           </a:solidFill>
                         </a:rPr>
                         <a:t>Block Kit proposals with approve/reject and HMAC-verified callbacks</a:t>
@@ -10854,7 +10111,7 @@
                   </a:txBody>
                   <a:tcPr>
                     <a:solidFill>
-                      <a:srgbClr val="F0F4F8"/>
+                      <a:srgbClr val="FAFAFA"/>
                     </a:solidFill>
                   </a:tcPr>
                 </a:tc>
@@ -10867,7 +10124,7 @@
                       <a:r>
                         <a:rPr sz="1200">
                           <a:solidFill>
-                            <a:srgbClr val="0D1B2A"/>
+                            <a:srgbClr val="1F2A37"/>
                           </a:solidFill>
                         </a:rPr>
                         <a:t>Approvals from existing team tools</a:t>
@@ -10876,7 +10133,7 @@
                   </a:txBody>
                   <a:tcPr>
                     <a:solidFill>
-                      <a:srgbClr val="F0F4F8"/>
+                      <a:srgbClr val="FAFAFA"/>
                     </a:solidFill>
                   </a:tcPr>
                 </a:tc>
@@ -10900,7 +10157,7 @@
             <a:avLst/>
           </a:prstGeom>
           <a:solidFill>
-            <a:srgbClr val="0D1B2A"/>
+            <a:srgbClr val="1F2A37"/>
           </a:solidFill>
           <a:ln>
             <a:noFill/>
@@ -10954,10 +10211,10 @@
             <a:r>
               <a:rPr sz="900" b="0" i="0">
                 <a:solidFill>
-                  <a:srgbClr val="647487"/>
-                </a:solidFill>
-              </a:rPr>
-              <a:t>SAGE[ai] — Open Source (Apache 2.0) | github.com/Sumanharapanahalli/sage | March 2026</a:t>
+                  <a:srgbClr val="4B5563"/>
+                </a:solidFill>
+              </a:rPr>
+              <a:t>SAGE[ai] — Open Source (MIT) | github.com/Sumanharapanahalli/sage | March 2026</a:t>
             </a:r>
           </a:p>
         </p:txBody>
@@ -10976,7 +10233,7 @@
     <p:bg>
       <p:bgPr>
         <a:solidFill>
-          <a:srgbClr val="F0F4F8"/>
+          <a:srgbClr val="FAFAFA"/>
         </a:solidFill>
         <a:effectLst/>
       </p:bgPr>
@@ -11003,7 +10260,7 @@
             <a:avLst/>
           </a:prstGeom>
           <a:solidFill>
-            <a:srgbClr val="0D1B2A"/>
+            <a:srgbClr val="1F2A37"/>
           </a:solidFill>
           <a:ln>
             <a:noFill/>
@@ -11091,7 +10348,7 @@
             <a:r>
               <a:rPr sz="1600" b="0" i="0">
                 <a:solidFill>
-                  <a:srgbClr val="00B4D8"/>
+                  <a:srgbClr val="047857"/>
                 </a:solidFill>
               </a:rPr>
               <a:t>Architecture decisions that compound advantage over time</a:t>
@@ -11114,7 +10371,7 @@
             <a:avLst/>
           </a:prstGeom>
           <a:solidFill>
-            <a:srgbClr val="0078D4"/>
+            <a:srgbClr val="10B981"/>
           </a:solidFill>
           <a:ln>
             <a:noFill/>
@@ -11168,7 +10425,7 @@
             <a:r>
               <a:rPr sz="1400" b="1" i="0">
                 <a:solidFill>
-                  <a:srgbClr val="0078D4"/>
+                  <a:srgbClr val="10B981"/>
                 </a:solidFill>
               </a:rPr>
               <a:t>Compliance by Design</a:t>
@@ -11202,7 +10459,7 @@
             <a:r>
               <a:rPr sz="1200" b="0" i="0">
                 <a:solidFill>
-                  <a:srgbClr val="0D1B2A"/>
+                  <a:srgbClr val="1F2A37"/>
                 </a:solidFill>
               </a:rPr>
               <a:t>Human approval gate is enforced in code — never optional. Audit trail is append-only. Built for FDA 21 CFR Part 11 and ISO 13485 from day one, not retrofitted.</a:t>
@@ -11225,7 +10482,7 @@
             <a:avLst/>
           </a:prstGeom>
           <a:solidFill>
-            <a:srgbClr val="0078D4"/>
+            <a:srgbClr val="10B981"/>
           </a:solidFill>
           <a:ln>
             <a:noFill/>
@@ -11279,7 +10536,7 @@
             <a:r>
               <a:rPr sz="1400" b="1" i="0">
                 <a:solidFill>
-                  <a:srgbClr val="0078D4"/>
+                  <a:srgbClr val="10B981"/>
                 </a:solidFill>
               </a:rPr>
               <a:t>Compounding Intelligence</a:t>
@@ -11313,7 +10570,7 @@
             <a:r>
               <a:rPr sz="1200" b="0" i="0">
                 <a:solidFill>
-                  <a:srgbClr val="0D1B2A"/>
+                  <a:srgbClr val="1F2A37"/>
                 </a:solidFill>
               </a:rPr>
               <a:t>Every human correction is stored in the vector database. Future agent quality improves without model retraining. Behavioral improvement decouples from LLM cost.</a:t>
@@ -11336,7 +10593,7 @@
             <a:avLst/>
           </a:prstGeom>
           <a:solidFill>
-            <a:srgbClr val="0078D4"/>
+            <a:srgbClr val="10B981"/>
           </a:solidFill>
           <a:ln>
             <a:noFill/>
@@ -11390,7 +10647,7 @@
             <a:r>
               <a:rPr sz="1400" b="1" i="0">
                 <a:solidFill>
-                  <a:srgbClr val="0078D4"/>
+                  <a:srgbClr val="10B981"/>
                 </a:solidFill>
               </a:rPr>
               <a:t>YAML-First Architecture</a:t>
@@ -11424,7 +10681,7 @@
             <a:r>
               <a:rPr sz="1200" b="0" i="0">
                 <a:solidFill>
-                  <a:srgbClr val="0D1B2A"/>
+                  <a:srgbClr val="1F2A37"/>
                 </a:solidFill>
               </a:rPr>
               <a:t>New domain equals 3 YAML files and zero code changes. The framework is domain-blind. Vertical expansion requires no additional engineering time.</a:t>
@@ -11447,7 +10704,7 @@
             <a:avLst/>
           </a:prstGeom>
           <a:solidFill>
-            <a:srgbClr val="0078D4"/>
+            <a:srgbClr val="10B981"/>
           </a:solidFill>
           <a:ln>
             <a:noFill/>
@@ -11501,7 +10758,7 @@
             <a:r>
               <a:rPr sz="1400" b="1" i="0">
                 <a:solidFill>
-                  <a:srgbClr val="0078D4"/>
+                  <a:srgbClr val="10B981"/>
                 </a:solidFill>
               </a:rPr>
               <a:t>No API Key Lock-In</a:t>
@@ -11535,7 +10792,7 @@
             <a:r>
               <a:rPr sz="1200" b="0" i="0">
                 <a:solidFill>
-                  <a:srgbClr val="0D1B2A"/>
+                  <a:srgbClr val="1F2A37"/>
                 </a:solidFill>
               </a:rPr>
               <a:t>Five LLM providers work without API keys — Gemini CLI, Claude Code, Ollama, local models, and any CLI tool. Customers own their inference and data.</a:t>
@@ -11558,7 +10815,7 @@
             <a:avLst/>
           </a:prstGeom>
           <a:solidFill>
-            <a:srgbClr val="0078D4"/>
+            <a:srgbClr val="10B981"/>
           </a:solidFill>
           <a:ln>
             <a:noFill/>
@@ -11612,7 +10869,7 @@
             <a:r>
               <a:rPr sz="1400" b="1" i="0">
                 <a:solidFill>
-                  <a:srgbClr val="0078D4"/>
+                  <a:srgbClr val="10B981"/>
                 </a:solidFill>
               </a:rPr>
               <a:t>Provider Agnostic</a:t>
@@ -11646,7 +10903,7 @@
             <a:r>
               <a:rPr sz="1200" b="0" i="0">
                 <a:solidFill>
-                  <a:srgbClr val="0D1B2A"/>
+                  <a:srgbClr val="1F2A37"/>
                 </a:solidFill>
               </a:rPr>
               <a:t>A single config change swaps LLM providers — OpenAI to Ollama to Anthropic. No vendor lock-in at the infrastructure level.</a:t>
@@ -11669,7 +10926,7 @@
             <a:avLst/>
           </a:prstGeom>
           <a:solidFill>
-            <a:srgbClr val="0D1B2A"/>
+            <a:srgbClr val="1F2A37"/>
           </a:solidFill>
           <a:ln>
             <a:noFill/>
@@ -11723,10 +10980,10 @@
             <a:r>
               <a:rPr sz="900" b="0" i="0">
                 <a:solidFill>
-                  <a:srgbClr val="647487"/>
-                </a:solidFill>
-              </a:rPr>
-              <a:t>SAGE[ai] — Open Source (Apache 2.0) | github.com/Sumanharapanahalli/sage | March 2026</a:t>
+                  <a:srgbClr val="4B5563"/>
+                </a:solidFill>
+              </a:rPr>
+              <a:t>SAGE[ai] — Open Source (MIT) | github.com/Sumanharapanahalli/sage | March 2026</a:t>
             </a:r>
           </a:p>
         </p:txBody>
@@ -11745,7 +11002,7 @@
     <p:bg>
       <p:bgPr>
         <a:solidFill>
-          <a:srgbClr val="F0F4F8"/>
+          <a:srgbClr val="FAFAFA"/>
         </a:solidFill>
         <a:effectLst/>
       </p:bgPr>
@@ -11772,7 +11029,7 @@
             <a:avLst/>
           </a:prstGeom>
           <a:solidFill>
-            <a:srgbClr val="0D1B2A"/>
+            <a:srgbClr val="1F2A37"/>
           </a:solidFill>
           <a:ln>
             <a:noFill/>
@@ -11860,7 +11117,7 @@
             <a:r>
               <a:rPr sz="1600" b="0" i="0">
                 <a:solidFill>
-                  <a:srgbClr val="00B4D8"/>
+                  <a:srgbClr val="047857"/>
                 </a:solidFill>
               </a:rPr>
               <a:t>Recurring revenue with high retention — switching cost grows as vector memory accumulates</a:t>
@@ -11883,7 +11140,7 @@
             <a:avLst/>
           </a:prstGeom>
           <a:solidFill>
-            <a:srgbClr val="0D1B2A"/>
+            <a:srgbClr val="1F2A37"/>
           </a:solidFill>
           <a:ln>
             <a:noFill/>
@@ -11971,7 +11228,7 @@
             <a:r>
               <a:rPr sz="1200" b="0" i="1">
                 <a:solidFill>
-                  <a:srgbClr val="00B4D8"/>
+                  <a:srgbClr val="047857"/>
                 </a:solidFill>
               </a:rPr>
               <a:t>Platform revenue streams</a:t>
@@ -12130,7 +11387,7 @@
             <a:avLst/>
           </a:prstGeom>
           <a:solidFill>
-            <a:srgbClr val="0078D4"/>
+            <a:srgbClr val="10B981"/>
           </a:solidFill>
           <a:ln>
             <a:noFill/>
@@ -12218,7 +11475,7 @@
             <a:r>
               <a:rPr sz="1200" b="0" i="1">
                 <a:solidFill>
-                  <a:srgbClr val="00B4D8"/>
+                  <a:srgbClr val="047857"/>
                 </a:solidFill>
               </a:rPr>
               <a:t>Engagement and support revenue</a:t>
@@ -12388,7 +11645,7 @@
             <a:r>
               <a:rPr sz="1100" b="1" i="1">
                 <a:solidFill>
-                  <a:srgbClr val="0D1B2A"/>
+                  <a:srgbClr val="1F2A37"/>
                 </a:solidFill>
               </a:rPr>
               <a:t>Target gross margin: 75-80% on software, 40-50% on services. Blended target: 65%+*</a:t>
@@ -12411,7 +11668,7 @@
             <a:avLst/>
           </a:prstGeom>
           <a:solidFill>
-            <a:srgbClr val="0D1B2A"/>
+            <a:srgbClr val="1F2A37"/>
           </a:solidFill>
           <a:ln>
             <a:noFill/>
@@ -12465,10 +11722,10 @@
             <a:r>
               <a:rPr sz="900" b="0" i="0">
                 <a:solidFill>
-                  <a:srgbClr val="647487"/>
-                </a:solidFill>
-              </a:rPr>
-              <a:t>SAGE[ai] — Open Source (Apache 2.0) | github.com/Sumanharapanahalli/sage | March 2026</a:t>
+                  <a:srgbClr val="4B5563"/>
+                </a:solidFill>
+              </a:rPr>
+              <a:t>SAGE[ai] — Open Source (MIT) | github.com/Sumanharapanahalli/sage | March 2026</a:t>
             </a:r>
           </a:p>
         </p:txBody>
@@ -12564,7 +11821,7 @@
     <p:bg>
       <p:bgPr>
         <a:solidFill>
-          <a:srgbClr val="F0F4F8"/>
+          <a:srgbClr val="FAFAFA"/>
         </a:solidFill>
         <a:effectLst/>
       </p:bgPr>
@@ -12591,7 +11848,7 @@
             <a:avLst/>
           </a:prstGeom>
           <a:solidFill>
-            <a:srgbClr val="0D1B2A"/>
+            <a:srgbClr val="1F2A37"/>
           </a:solidFill>
           <a:ln>
             <a:noFill/>
@@ -12679,7 +11936,7 @@
             <a:r>
               <a:rPr sz="1600" b="0" i="0">
                 <a:solidFill>
-                  <a:srgbClr val="00B4D8"/>
+                  <a:srgbClr val="047857"/>
                 </a:solidFill>
               </a:rPr>
               <a:t>SAGE is purpose-built for regulated industries — no direct equivalent exists today</a:t>
@@ -12729,7 +11986,7 @@
                   </a:txBody>
                   <a:tcPr>
                     <a:solidFill>
-                      <a:srgbClr val="0078D4"/>
+                      <a:srgbClr val="10B981"/>
                     </a:solidFill>
                   </a:tcPr>
                 </a:tc>
@@ -12751,7 +12008,7 @@
                   </a:txBody>
                   <a:tcPr>
                     <a:solidFill>
-                      <a:srgbClr val="0078D4"/>
+                      <a:srgbClr val="10B981"/>
                     </a:solidFill>
                   </a:tcPr>
                 </a:tc>
@@ -12773,7 +12030,7 @@
                   </a:txBody>
                   <a:tcPr>
                     <a:solidFill>
-                      <a:srgbClr val="0078D4"/>
+                      <a:srgbClr val="10B981"/>
                     </a:solidFill>
                   </a:tcPr>
                 </a:tc>
@@ -12788,7 +12045,7 @@
                       <a:r>
                         <a:rPr sz="1200">
                           <a:solidFill>
-                            <a:srgbClr val="0D1B2A"/>
+                            <a:srgbClr val="1F2A37"/>
                           </a:solidFill>
                         </a:rPr>
                         <a:t>General AI coding assistants</a:t>
@@ -12797,7 +12054,7 @@
                   </a:txBody>
                   <a:tcPr>
                     <a:solidFill>
-                      <a:srgbClr val="F0F4F8"/>
+                      <a:srgbClr val="FAFAFA"/>
                     </a:solidFill>
                   </a:tcPr>
                 </a:tc>
@@ -12810,7 +12067,7 @@
                       <a:r>
                         <a:rPr sz="1200">
                           <a:solidFill>
-                            <a:srgbClr val="0D1B2A"/>
+                            <a:srgbClr val="1F2A37"/>
                           </a:solidFill>
                         </a:rPr>
                         <a:t>GitHub Copilot, Cursor, Codeium</a:t>
@@ -12819,7 +12076,7 @@
                   </a:txBody>
                   <a:tcPr>
                     <a:solidFill>
-                      <a:srgbClr val="F0F4F8"/>
+                      <a:srgbClr val="FAFAFA"/>
                     </a:solidFill>
                   </a:tcPr>
                 </a:tc>
@@ -12832,7 +12089,7 @@
                       <a:r>
                         <a:rPr sz="1200">
                           <a:solidFill>
-                            <a:srgbClr val="0D1B2A"/>
+                            <a:srgbClr val="1F2A37"/>
                           </a:solidFill>
                         </a:rPr>
                         <a:t>No audit trail, no compliance gate, no domain memory</a:t>
@@ -12841,7 +12098,7 @@
                   </a:txBody>
                   <a:tcPr>
                     <a:solidFill>
-                      <a:srgbClr val="F0F4F8"/>
+                      <a:srgbClr val="FAFAFA"/>
                     </a:solidFill>
                   </a:tcPr>
                 </a:tc>
@@ -12856,7 +12113,7 @@
                       <a:r>
                         <a:rPr sz="1200">
                           <a:solidFill>
-                            <a:srgbClr val="0D1B2A"/>
+                            <a:srgbClr val="1F2A37"/>
                           </a:solidFill>
                         </a:rPr>
                         <a:t>Enterprise LLM platforms</a:t>
@@ -12878,7 +12135,7 @@
                       <a:r>
                         <a:rPr sz="1200">
                           <a:solidFill>
-                            <a:srgbClr val="0D1B2A"/>
+                            <a:srgbClr val="1F2A37"/>
                           </a:solidFill>
                         </a:rPr>
                         <a:t>Azure OpenAI, AWS Bedrock</a:t>
@@ -12900,7 +12157,7 @@
                       <a:r>
                         <a:rPr sz="1200">
                           <a:solidFill>
-                            <a:srgbClr val="0D1B2A"/>
+                            <a:srgbClr val="1F2A37"/>
                           </a:solidFill>
                         </a:rPr>
                         <a:t>Infrastructure only — no agent logic, no approval workflow</a:t>
@@ -12924,7 +12181,7 @@
                       <a:r>
                         <a:rPr sz="1200">
                           <a:solidFill>
-                            <a:srgbClr val="0D1B2A"/>
+                            <a:srgbClr val="1F2A37"/>
                           </a:solidFill>
                         </a:rPr>
                         <a:t>AI workflow automation</a:t>
@@ -12933,7 +12190,7 @@
                   </a:txBody>
                   <a:tcPr>
                     <a:solidFill>
-                      <a:srgbClr val="F0F4F8"/>
+                      <a:srgbClr val="FAFAFA"/>
                     </a:solidFill>
                   </a:tcPr>
                 </a:tc>
@@ -12946,7 +12203,7 @@
                       <a:r>
                         <a:rPr sz="1200">
                           <a:solidFill>
-                            <a:srgbClr val="0D1B2A"/>
+                            <a:srgbClr val="1F2A37"/>
                           </a:solidFill>
                         </a:rPr>
                         <a:t>n8n, Zapier AI, Make</a:t>
@@ -12955,7 +12212,7 @@
                   </a:txBody>
                   <a:tcPr>
                     <a:solidFill>
-                      <a:srgbClr val="F0F4F8"/>
+                      <a:srgbClr val="FAFAFA"/>
                     </a:solidFill>
                   </a:tcPr>
                 </a:tc>
@@ -12968,7 +12225,7 @@
                       <a:r>
                         <a:rPr sz="1200">
                           <a:solidFill>
-                            <a:srgbClr val="0D1B2A"/>
+                            <a:srgbClr val="1F2A37"/>
                           </a:solidFill>
                         </a:rPr>
                         <a:t>No domain intelligence, no vector memory, no compliance layer</a:t>
@@ -12977,7 +12234,7 @@
                   </a:txBody>
                   <a:tcPr>
                     <a:solidFill>
-                      <a:srgbClr val="F0F4F8"/>
+                      <a:srgbClr val="FAFAFA"/>
                     </a:solidFill>
                   </a:tcPr>
                 </a:tc>
@@ -12992,7 +12249,7 @@
                       <a:r>
                         <a:rPr sz="1200">
                           <a:solidFill>
-                            <a:srgbClr val="0D1B2A"/>
+                            <a:srgbClr val="1F2A37"/>
                           </a:solidFill>
                         </a:rPr>
                         <a:t>Vertical AI point solutions</a:t>
@@ -13014,7 +12271,7 @@
                       <a:r>
                         <a:rPr sz="1200">
                           <a:solidFill>
-                            <a:srgbClr val="0D1B2A"/>
+                            <a:srgbClr val="1F2A37"/>
                           </a:solidFill>
                         </a:rPr>
                         <a:t>Veeva, Sparta Systems TrackWise</a:t>
@@ -13036,7 +12293,7 @@
                       <a:r>
                         <a:rPr sz="1200">
                           <a:solidFill>
-                            <a:srgbClr val="0D1B2A"/>
+                            <a:srgbClr val="1F2A37"/>
                           </a:solidFill>
                         </a:rPr>
                         <a:t>Single-function, expensive, not extensible to engineering workflows</a:t>
@@ -13060,7 +12317,7 @@
                       <a:r>
                         <a:rPr sz="1200">
                           <a:solidFill>
-                            <a:srgbClr val="0D1B2A"/>
+                            <a:srgbClr val="1F2A37"/>
                           </a:solidFill>
                         </a:rPr>
                         <a:t>Open-source agent frameworks</a:t>
@@ -13069,7 +12326,7 @@
                   </a:txBody>
                   <a:tcPr>
                     <a:solidFill>
-                      <a:srgbClr val="F0F4F8"/>
+                      <a:srgbClr val="FAFAFA"/>
                     </a:solidFill>
                   </a:tcPr>
                 </a:tc>
@@ -13082,7 +12339,7 @@
                       <a:r>
                         <a:rPr sz="1200">
                           <a:solidFill>
-                            <a:srgbClr val="0D1B2A"/>
+                            <a:srgbClr val="1F2A37"/>
                           </a:solidFill>
                         </a:rPr>
                         <a:t>LangChain, AutoGen, CrewAI</a:t>
@@ -13091,7 +12348,7 @@
                   </a:txBody>
                   <a:tcPr>
                     <a:solidFill>
-                      <a:srgbClr val="F0F4F8"/>
+                      <a:srgbClr val="FAFAFA"/>
                     </a:solidFill>
                   </a:tcPr>
                 </a:tc>
@@ -13104,7 +12361,7 @@
                       <a:r>
                         <a:rPr sz="1200">
                           <a:solidFill>
-                            <a:srgbClr val="0D1B2A"/>
+                            <a:srgbClr val="1F2A37"/>
                           </a:solidFill>
                         </a:rPr>
                         <a:t>No production harness, no compliance, no UI — integration required</a:t>
@@ -13113,7 +12370,7 @@
                   </a:txBody>
                   <a:tcPr>
                     <a:solidFill>
-                      <a:srgbClr val="F0F4F8"/>
+                      <a:srgbClr val="FAFAFA"/>
                     </a:solidFill>
                   </a:tcPr>
                 </a:tc>
@@ -13128,7 +12385,7 @@
                       <a:r>
                         <a:rPr sz="1200">
                           <a:solidFill>
-                            <a:srgbClr val="0D1B2A"/>
+                            <a:srgbClr val="1F2A37"/>
                           </a:solidFill>
                         </a:rPr>
                         <a:t>SAGE Framework</a:t>
@@ -13150,7 +12407,7 @@
                       <a:r>
                         <a:rPr sz="1200">
                           <a:solidFill>
-                            <a:srgbClr val="0D1B2A"/>
+                            <a:srgbClr val="1F2A37"/>
                           </a:solidFill>
                         </a:rPr>
                         <a:t>Purpose-built for regulated engineering</a:t>
@@ -13172,7 +12429,7 @@
                       <a:r>
                         <a:rPr sz="1200">
                           <a:solidFill>
-                            <a:srgbClr val="0D1B2A"/>
+                            <a:srgbClr val="1F2A37"/>
                           </a:solidFill>
                         </a:rPr>
                         <a:t>Full stack: compliance, agents, memory, UI, no API key required</a:t>
@@ -13205,7 +12462,7 @@
             <a:avLst/>
           </a:prstGeom>
           <a:solidFill>
-            <a:srgbClr val="0D1B2A"/>
+            <a:srgbClr val="1F2A37"/>
           </a:solidFill>
           <a:ln>
             <a:noFill/>
@@ -13259,10 +12516,10 @@
             <a:r>
               <a:rPr sz="900" b="0" i="0">
                 <a:solidFill>
-                  <a:srgbClr val="647487"/>
-                </a:solidFill>
-              </a:rPr>
-              <a:t>SAGE[ai] — Open Source (Apache 2.0) | github.com/Sumanharapanahalli/sage | March 2026</a:t>
+                  <a:srgbClr val="4B5563"/>
+                </a:solidFill>
+              </a:rPr>
+              <a:t>SAGE[ai] — Open Source (MIT) | github.com/Sumanharapanahalli/sage | March 2026</a:t>
             </a:r>
           </a:p>
         </p:txBody>

</xml_diff>